<commit_message>
Enforce customer-centric 3-Act Outside-In & Top-Down architecture progression across all 5 workstream blogs and slide decks (WS1-WS5 & ALL)
</commit_message>
<xml_diff>
--- a/slides/doc-mt-02-editable-slides.pptx
+++ b/slides/doc-mt-02-editable-slides.pptx
@@ -1139,11 +1139,11 @@
           <a:p>
             <a:r>
               <a:rPr lang="en-US" dirty="0"/>
-              <a:t>Use cases — FinVault Bank &amp; RetailStream Corp Co-Hosted Safely
-• Dynamic Per-Turn Runtime Hydration: A single pooled Diagnostic Agent dynamically loads each caller’s Firestore profile, GCS Skills (`gs://cymbal-skills-{tenant}/`), and token caps on every turn.
-• FinVault Bank (Enterprise Slice in Pool): Authenticates via Google Workspace OIDC, unlocks an 8,000-token thinking budget and 600 RPM quota, and accesses private Agent Alpha plus Workspace/Jira 3LO.
-• RetailStream Corp (Standard Slice in Pool): Authenticates via Microsoft Entra ID OIDC, runs within a 4,000-token thinking cap and 120 RPM quota, and invokes SharePoint/ServiceNow 3LO with employee consent.
-• Strict Catalog &amp; Namespace Firewall: RetailStream’s catalog discovery call excludes FinVault’s Agent Alpha (HTTP 403), and cross-tenant L4 Episodic Memory Bank reads throw an immediate PermissionError.</a:t>
+              <a:t>Use cases — Co-Hosting FinVault &amp; RetailStream Safely on One Pooled Google Cloud Stack
+• Dynamic Per-Turn Runtime Hydration: A single pooled Diagnostic Agent on Cloud Run v2 &amp; Vertex AI Agent Engine dynamically loads each caller’s Firestore profile, GCS Skills (`gs://cymbal-skills-{tenant}/`), and 32k Gemini 2.5 Pro ContextCacheConfig prefix.
+• FinVault Bank (Enterprise Slice in Pool): Authenticates via Google Workspace OIDC, unlocks an 8,000-token thinking budget and 600 RPM Valkey quota, and accesses private Agent Alpha (Gemini 2.5 Pro Dedicated PT) plus Workspace/Jira 3LO.
+• RetailStream Corp (Standard Slice in Pool): Authenticates via Microsoft Entra ID OIDC, runs within a 4,000-token thinking cap and 120 RPM Valkey quota ($42/mo floor), and invokes SharePoint/ServiceNow 3LO with `-32042` step-up consent.
+• Cryptographic Catalog, Memory &amp; AlloyDB RLS Firewall: Cloud Armor, IAP OBO/DPoP, Hop 2 ARD Filter (HTTP 403), Hop 3 L1–L5 Memory Bank namespaces, Hop 4 Model Armor/DLP, and Hop 5 AlloyDB FORCE RLS guarantee 100% mutual invisibility.</a:t>
             </a:r>
             <a:endParaRPr lang="en-US" dirty="0"/>
           </a:p>
@@ -1231,11 +1231,8 @@
           <a:p>
             <a:r>
               <a:rPr lang="en-US" dirty="0"/>
-              <a:t>Products used — Shared Cloud Run v2, Vertex AI, Valkey &amp; AlloyDB RLS
-• Agentic AI &amp; Shared Prefix Caching: Vertex AI Agent Engine (ADK 2.0 runtime, Agent Registry &amp; L1–L5 Memory Bank) and Gemini 2.5 Pro with ContextCacheConfig caching a 32,000-token immutable system prefix at a 90% discount (84.7% net token savings).
-• Ingress, Identity &amp; Bidirectional AI Safety: Global External Application Load Balancer, Google Cloud Armor L7 WAF (stripping spoofed X-Tenant-Id headers), IAP + IAM STS (RFC 8693 OBO + RFC 9449 DPoP), Vertex AI Model Armor, and Cloud Sensitive Data Protection.
-• Rate Bulkheads, Relational RLS &amp; FinOps Telemetry: Memorystore for Valkey (120 vs. 600 RPM token buckets), Firestore tenant profile registry, AlloyDB for PostgreSQL (`FORCE ROW LEVEL SECURITY`), Cloud KMS CMEK, and BigQuery zero-PII OTel chargeback.
-• High-Density Unit Economics ($42/Tenant/Month): Co-hosts hundreds of commercial B2B SaaS tenants inside one shared Google Cloud project (`ramp-portal-dev`) while guaranteeing 10/10 red-team breach isolation.</a:t>
+              <a:t>Design alternatives — Pattern A Pooled Architecture vs. Naive Multi-Tenancy vs. Dedicated Silos
+</a:t>
             </a:r>
             <a:endParaRPr lang="en-US" dirty="0"/>
           </a:p>
@@ -17226,7 +17223,7 @@
                 <a:ea typeface="Google Sans" pitchFamily="34" charset="-122"/>
                 <a:cs typeface="Google Sans" pitchFamily="34" charset="-120"/>
               </a:rPr>
-              <a:t>FinVault Bank &amp; RetailStream Corp Co-Hosted Safely</a:t>
+              <a:t>Co-Hosting FinVault &amp; RetailStream Safely on One Pooled Google Cloud Stack</a:t>
             </a:r>
             <a:endParaRPr lang="en-US" sz="1900" dirty="0"/>
           </a:p>
@@ -17471,7 +17468,7 @@
                 <a:ea typeface="Roboto" pitchFamily="34" charset="-122"/>
                 <a:cs typeface="Roboto" pitchFamily="34" charset="-120"/>
               </a:rPr>
-              <a:t>A single pooled Diagnostic Agent dynamically loads each caller’s Firestore profile, GCS Skills (gs://cymbal-skills-{tenant}/), and token caps on every turn.</a:t>
+              <a:t>A single pooled Diagnostic Agent on Cloud Run v2 &amp; Vertex AI Agent Engine dynamically loads each caller’s Firestore profile, GCS Skills (gs://cymbal-skills-{tenant}/), and 32k Gemini 2.5 Pro ContextCacheConfig prefix.</a:t>
             </a:r>
             <a:endParaRPr lang="en-US" sz="980" dirty="0"/>
           </a:p>
@@ -17557,7 +17554,7 @@
                 <a:ea typeface="Google Sans" pitchFamily="34" charset="-122"/>
                 <a:cs typeface="Google Sans" pitchFamily="34" charset="-120"/>
               </a:rPr>
-              <a:t>Cloud Stack: core-cymbal-agent/runtime_pipeline.py • Hop3RuntimeAndMemory.load_dynamic_runtime_config
+              <a:t>Cloud Stack: Cloud Run v2 • Vertex AI Agent Engine • Gemini 2.5 Pro ContextCacheConfig (32k Prefix)
 </a:t>
             </a:r>
             <a:pPr indent="0" marL="0">
@@ -17572,7 +17569,7 @@
                 <a:ea typeface="Roboto" pitchFamily="34" charset="-122"/>
                 <a:cs typeface="Roboto" pitchFamily="34" charset="-120"/>
               </a:rPr>
-              <a:t>Target &amp; SLA: Injects Tenant-Specific System Prompt &amp; Verified GCS Skills URIs per Turn</a:t>
+              <a:t>Target &amp; SLA: Injects Tenant-Specific Prompt &amp; GCS Skills per Turn • 84.7% Net Input Token Cost Reduction</a:t>
             </a:r>
             <a:endParaRPr lang="en-US" sz="750" dirty="0"/>
           </a:p>
@@ -17633,7 +17630,7 @@
                 <a:ea typeface="Google Sans" pitchFamily="34" charset="-122"/>
                 <a:cs typeface="Google Sans" pitchFamily="34" charset="-120"/>
               </a:rPr>
-              <a:t>Dynamic Context Hydration</a:t>
+              <a:t>1. Shared Pooled Control Plane</a:t>
             </a:r>
             <a:endParaRPr lang="en-US" sz="750" dirty="0"/>
           </a:p>
@@ -17839,7 +17836,7 @@
                 <a:ea typeface="Roboto" pitchFamily="34" charset="-122"/>
                 <a:cs typeface="Roboto" pitchFamily="34" charset="-120"/>
               </a:rPr>
-              <a:t>Authenticates via Google Workspace OIDC, unlocks an 8,000-token thinking budget and 600 RPM quota, and accesses private Agent Alpha plus Workspace/Jira 3LO.</a:t>
+              <a:t>Authenticates via Google Workspace OIDC, unlocks an 8,000-token thinking budget and 600 RPM Valkey quota, and accesses private Agent Alpha (Gemini 2.5 Pro Dedicated PT) plus Workspace/Jira 3LO.</a:t>
             </a:r>
             <a:endParaRPr lang="en-US" sz="980" dirty="0"/>
           </a:p>
@@ -17925,7 +17922,7 @@
                 <a:ea typeface="Google Sans" pitchFamily="34" charset="-122"/>
                 <a:cs typeface="Google Sans" pitchFamily="34" charset="-120"/>
               </a:rPr>
-              <a:t>Cloud Stack: Google Workspace OIDC • Agent Alpha (Gemini 2.5 Pro / Gemini 2.5) • 3LO Drive/Gmail/Jira
+              <a:t>Cloud Stack: Google Workspace OIDC • Agent Alpha (Gemini 2.5 Pro Dedicated PT) • 3LO Drive/Gmail/Jira
 </a:t>
             </a:r>
             <a:pPr indent="0" marL="0">
@@ -17940,7 +17937,7 @@
                 <a:ea typeface="Roboto" pitchFamily="34" charset="-122"/>
                 <a:cs typeface="Roboto" pitchFamily="34" charset="-120"/>
               </a:rPr>
-              <a:t>Target &amp; SLA: 8,000 Thinking Tokens • 600 RPM Valkey Bucket • OCC NLC + IBAN/SWIFT Masking</a:t>
+              <a:t>Target &amp; SLA: 8,000 Thinking Tokens • 600 RPM Valkey Bucket • OCC NLC (HTTP 422) + IBAN/SWIFT Masking</a:t>
             </a:r>
             <a:endParaRPr lang="en-US" sz="750" dirty="0"/>
           </a:p>
@@ -18001,7 +17998,7 @@
                 <a:ea typeface="Google Sans" pitchFamily="34" charset="-122"/>
                 <a:cs typeface="Google Sans" pitchFamily="34" charset="-120"/>
               </a:rPr>
-              <a:t>FinVault Pooled Slice</a:t>
+              <a:t>2. FinVault Pooled Enterprise Slice</a:t>
             </a:r>
             <a:endParaRPr lang="en-US" sz="750" dirty="0"/>
           </a:p>
@@ -18207,7 +18204,7 @@
                 <a:ea typeface="Roboto" pitchFamily="34" charset="-122"/>
                 <a:cs typeface="Roboto" pitchFamily="34" charset="-120"/>
               </a:rPr>
-              <a:t>Authenticates via Microsoft Entra ID OIDC, runs within a 4,000-token thinking cap and 120 RPM quota, and invokes SharePoint/ServiceNow 3LO with employee consent.</a:t>
+              <a:t>Authenticates via Microsoft Entra ID OIDC, runs within a 4,000-token thinking cap and 120 RPM Valkey quota ($42/mo floor), and invokes SharePoint/ServiceNow 3LO with -32042 step-up consent.</a:t>
             </a:r>
             <a:endParaRPr lang="en-US" sz="980" dirty="0"/>
           </a:p>
@@ -18293,7 +18290,7 @@
                 <a:ea typeface="Google Sans" pitchFamily="34" charset="-122"/>
                 <a:cs typeface="Google Sans" pitchFamily="34" charset="-120"/>
               </a:rPr>
-              <a:t>Cloud Stack: Microsoft Entra ID OIDC • Shared Diagnostic Agent • 3LO SharePoint/ServiceNow
+              <a:t>Cloud Stack: Microsoft Entra ID OIDC • Shared Diagnostic Agent • 3LO SharePoint &amp; ServiceNow ITOM
 </a:t>
             </a:r>
             <a:pPr indent="0" marL="0">
@@ -18308,7 +18305,7 @@
                 <a:ea typeface="Roboto" pitchFamily="34" charset="-122"/>
                 <a:cs typeface="Roboto" pitchFamily="34" charset="-120"/>
               </a:rPr>
-              <a:t>Target &amp; SLA: 4,000 Thinking Tokens • 120 RPM Valkey Bucket • PCI-DSS PAN/SSN Masking</a:t>
+              <a:t>Target &amp; SLA: 4,000 Thinking Tokens • 120 RPM Valkey Bucket • PCI-DSS PAN/SSN Masking • $42/mo Floor</a:t>
             </a:r>
             <a:endParaRPr lang="en-US" sz="750" dirty="0"/>
           </a:p>
@@ -18369,7 +18366,7 @@
                 <a:ea typeface="Google Sans" pitchFamily="34" charset="-122"/>
                 <a:cs typeface="Google Sans" pitchFamily="34" charset="-120"/>
               </a:rPr>
-              <a:t>RetailStream Pooled Slice</a:t>
+              <a:t>3. RetailStream Pooled Standard Slice</a:t>
             </a:r>
             <a:endParaRPr lang="en-US" sz="750" dirty="0"/>
           </a:p>
@@ -18516,7 +18513,7 @@
                 <a:ea typeface="Google Sans" pitchFamily="34" charset="-122"/>
                 <a:cs typeface="Google Sans" pitchFamily="34" charset="-120"/>
               </a:rPr>
-              <a:t>Strict Catalog &amp; Namespace Firewall</a:t>
+              <a:t>Cryptographic Catalog, Memory &amp; AlloyDB RLS Firewall</a:t>
             </a:r>
             <a:endParaRPr lang="en-US" sz="1140" dirty="0"/>
           </a:p>
@@ -18575,7 +18572,7 @@
                 <a:ea typeface="Roboto" pitchFamily="34" charset="-122"/>
                 <a:cs typeface="Roboto" pitchFamily="34" charset="-120"/>
               </a:rPr>
-              <a:t>RetailStream’s catalog discovery call excludes FinVault’s Agent Alpha (HTTP 403), and cross-tenant L4 Episodic Memory Bank reads throw an immediate PermissionError.</a:t>
+              <a:t>Cloud Armor, IAP OBO/DPoP, Hop 2 ARD Filter (HTTP 403), Hop 3 L1–L5 Memory Bank namespaces, Hop 4 Model Armor/DLP, and Hop 5 AlloyDB FORCE RLS guarantee 100% mutual invisibility.</a:t>
             </a:r>
             <a:endParaRPr lang="en-US" sz="980" dirty="0"/>
           </a:p>
@@ -18661,7 +18658,7 @@
                 <a:ea typeface="Google Sans" pitchFamily="34" charset="-122"/>
                 <a:cs typeface="Google Sans" pitchFamily="34" charset="-120"/>
               </a:rPr>
-              <a:t>Cloud Stack: Hop 2 ARD Filter + Hop 3 MemoryBankLevel.L1..L5 + Hop 5 PostgreSQL RLS
+              <a:t>Cloud Stack: Cloud Armor • IAP STS • Hop 2 ARD • L1–L5 Memory Bank • Model Armor • AlloyDB FORCE RLS
 </a:t>
             </a:r>
             <a:pPr indent="0" marL="0">
@@ -18676,7 +18673,7 @@
                 <a:ea typeface="Roboto" pitchFamily="34" charset="-122"/>
                 <a:cs typeface="Roboto" pitchFamily="34" charset="-120"/>
               </a:rPr>
-              <a:t>Target &amp; SLA: 100% Mutual Invisibility Between Co-Hosted Competing Tenants</a:t>
+              <a:t>Target &amp; SLA: 10/10 Adversarial Red-Team Breach Simulations Blocked • 0 Cross-Tenant SQL Rows</a:t>
             </a:r>
             <a:endParaRPr lang="en-US" sz="750" dirty="0"/>
           </a:p>
@@ -18737,7 +18734,7 @@
                 <a:ea typeface="Google Sans" pitchFamily="34" charset="-122"/>
                 <a:cs typeface="Google Sans" pitchFamily="34" charset="-120"/>
               </a:rPr>
-              <a:t>Cryptographic Partitioning</a:t>
+              <a:t>4. Unified Pattern A Security Stack</a:t>
             </a:r>
             <a:endParaRPr lang="en-US" sz="750" dirty="0"/>
           </a:p>
@@ -19306,7 +19303,7 @@
                 <a:ea typeface="Google Sans" pitchFamily="34" charset="-122"/>
                 <a:cs typeface="Google Sans" pitchFamily="34" charset="-120"/>
               </a:rPr>
-              <a:t>ACT I • GOOGLE CLOUD REFERENCE PRODUCT STACK &amp; BILL OF MATERIALS</a:t>
+              <a:t>ACT I • ARCHITECTURAL OPTIONS &amp; PATTERN A / B / C DECISION MATRIX</a:t>
             </a:r>
             <a:endParaRPr lang="en-US" sz="1020" dirty="0"/>
           </a:p>
@@ -19372,7 +19369,7 @@
                 <a:ea typeface="Roboto" pitchFamily="34" charset="-122"/>
                 <a:cs typeface="Roboto" pitchFamily="34" charset="-120"/>
               </a:rPr>
-              <a:t>THREE-PILLAR • ARCHITECTURE</a:t>
+              <a:t>COMPARISON-GRID • MATRIX</a:t>
             </a:r>
             <a:endParaRPr lang="en-US" sz="750" dirty="0"/>
           </a:p>
@@ -19386,8 +19383,8 @@
         </p:nvSpPr>
         <p:spPr>
           <a:xfrm>
-            <a:off x="411480" y="658368"/>
-            <a:ext cx="11368735" cy="365760"/>
+            <a:off x="411480" y="640080"/>
+            <a:ext cx="11368735" cy="347472"/>
           </a:xfrm>
           <a:prstGeom prst="rect">
             <a:avLst/>
@@ -19403,7 +19400,7 @@
               <a:buNone/>
             </a:pPr>
             <a:r>
-              <a:rPr lang="en-US" sz="1900" b="1" dirty="0">
+              <a:rPr lang="en-US" sz="1800" b="1" dirty="0">
                 <a:solidFill>
                   <a:srgbClr val="3C4043"/>
                 </a:solidFill>
@@ -19411,9 +19408,9 @@
                 <a:ea typeface="Google Sans" pitchFamily="34" charset="-122"/>
                 <a:cs typeface="Google Sans" pitchFamily="34" charset="-120"/>
               </a:rPr>
-              <a:t>Shared Cloud Run v2, Vertex AI, Valkey &amp; AlloyDB RLS</a:t>
-            </a:r>
-            <a:endParaRPr lang="en-US" sz="1900" dirty="0"/>
+              <a:t>Pattern A Pooled Architecture vs. Naive Multi-Tenancy vs. Dedicated Silos</a:t>
+            </a:r>
+            <a:endParaRPr lang="en-US" sz="1800" dirty="0"/>
           </a:p>
         </p:txBody>
       </p:sp>
@@ -19425,8 +19422,8 @@
         </p:nvSpPr>
         <p:spPr>
           <a:xfrm>
-            <a:off x="411480" y="1024128"/>
-            <a:ext cx="11368735" cy="237744"/>
+            <a:off x="411480" y="987552"/>
+            <a:ext cx="11368735" cy="219456"/>
           </a:xfrm>
           <a:prstGeom prst="rect">
             <a:avLst/>
@@ -19442,7 +19439,7 @@
               <a:buNone/>
             </a:pPr>
             <a:r>
-              <a:rPr lang="en-US" sz="1000" dirty="0">
+              <a:rPr lang="en-US" sz="980" dirty="0">
                 <a:solidFill>
                   <a:srgbClr val="5F6368"/>
                 </a:solidFill>
@@ -19450,26 +19447,1976 @@
                 <a:ea typeface="Roboto" pitchFamily="34" charset="-122"/>
                 <a:cs typeface="Roboto" pitchFamily="34" charset="-120"/>
               </a:rPr>
-              <a:t>Structured Google Cloud reference SKUs, runtime isolation boundaries, and production SLAs.</a:t>
-            </a:r>
-            <a:endParaRPr lang="en-US" sz="1000" dirty="0"/>
-          </a:p>
-        </p:txBody>
-      </p:sp>
-      <p:sp>
-        <p:nvSpPr>
-          <p:cNvPr id="19" name="Shape 17"/>
-          <p:cNvSpPr/>
-          <p:nvPr/>
-        </p:nvSpPr>
-        <p:spPr>
-          <a:xfrm>
-            <a:off x="411480" y="1353312"/>
-            <a:ext cx="5583326" cy="2258568"/>
+              <a:t>Side-by-side Google Cloud Well-Architected trade-off analysis, isolation boundaries, and unit economics.</a:t>
+            </a:r>
+            <a:endParaRPr lang="en-US" sz="980" dirty="0"/>
+          </a:p>
+        </p:txBody>
+      </p:sp>
+      <p:graphicFrame>
+        <p:nvGraphicFramePr>
+          <p:cNvPr id="5" name="Table 0"/>
+          <p:cNvGraphicFramePr>
+            <a:graphicFrameLocks noGrp="1"/>
+          </p:cNvGraphicFramePr>
+          <p:nvPr>
+            <p:extLst>
+              <p:ext uri="{D42A27DB-BD31-4B8C-83A1-F6EECF244321}">
+                <p14:modId xmlns:p14="http://schemas.microsoft.com/office/powerpoint/2010/main" val="1579011935"/>
+              </p:ext>
+            </p:extLst>
+          </p:nvPr>
+        </p:nvGraphicFramePr>
+        <p:xfrm>
+          <a:off x="411480" y="1243584"/>
+          <a:ext cx="11368735" cy="914400"/>
+        </p:xfrm>
+        <a:graphic>
+          <a:graphicData uri="http://schemas.openxmlformats.org/drawingml/2006/table">
+            <a:tbl>
+              <a:tblPr/>
+              <a:tblGrid>
+                <a:gridCol w="2057400"/>
+                <a:gridCol w="3017520"/>
+                <a:gridCol w="3200400"/>
+                <a:gridCol w="3184855"/>
+              </a:tblGrid>
+              <a:tr h="0">
+                <a:tc>
+                  <a:txBody>
+                    <a:bodyPr/>
+                    <a:lstStyle/>
+                    <a:p>
+                      <a:pPr indent="0" marL="0">
+                        <a:buNone/>
+                      </a:pPr>
+                      <a:r>
+                        <a:rPr lang="en-US" sz="850" b="1" dirty="0">
+                          <a:solidFill>
+                            <a:srgbClr val="FFFFFF"/>
+                          </a:solidFill>
+                          <a:latin typeface="Google Sans" pitchFamily="34" charset="0"/>
+                          <a:ea typeface="Google Sans" pitchFamily="34" charset="-122"/>
+                          <a:cs typeface="Google Sans" pitchFamily="34" charset="-120"/>
+                        </a:rPr>
+                        <a:t>Architectural Dimension</a:t>
+                      </a:r>
+                      <a:endParaRPr lang="en-US" sz="850" dirty="0">
+                        <a:latin typeface="Google Sans" charset="0"/>
+                        <a:ea typeface="Google Sans" charset="0"/>
+                        <a:cs typeface="Google Sans" charset="0"/>
+                      </a:endParaRPr>
+                    </a:p>
+                  </a:txBody>
+                  <a:tcPr marL="91440" marR="91440" marT="45720" marB="45720" anchor="ctr">
+                    <a:lnL w="9525" cap="flat" cmpd="sng" algn="ctr">
+                      <a:solidFill>
+                        <a:srgbClr val="DADCE0"/>
+                      </a:solidFill>
+                      <a:prstDash val="solid"/>
+                      <a:round/>
+                      <a:headEnd type="none" w="med" len="med"/>
+                      <a:tailEnd type="none" w="med" len="med"/>
+                    </a:lnL>
+                    <a:lnR w="9525" cap="flat" cmpd="sng" algn="ctr">
+                      <a:solidFill>
+                        <a:srgbClr val="DADCE0"/>
+                      </a:solidFill>
+                      <a:prstDash val="solid"/>
+                      <a:round/>
+                      <a:headEnd type="none" w="med" len="med"/>
+                      <a:tailEnd type="none" w="med" len="med"/>
+                    </a:lnR>
+                    <a:lnT w="9525" cap="flat" cmpd="sng" algn="ctr">
+                      <a:solidFill>
+                        <a:srgbClr val="DADCE0"/>
+                      </a:solidFill>
+                      <a:prstDash val="solid"/>
+                      <a:round/>
+                      <a:headEnd type="none" w="med" len="med"/>
+                      <a:tailEnd type="none" w="med" len="med"/>
+                    </a:lnT>
+                    <a:lnB w="9525" cap="flat" cmpd="sng" algn="ctr">
+                      <a:solidFill>
+                        <a:srgbClr val="DADCE0"/>
+                      </a:solidFill>
+                      <a:prstDash val="solid"/>
+                      <a:round/>
+                      <a:headEnd type="none" w="med" len="med"/>
+                      <a:tailEnd type="none" w="med" len="med"/>
+                    </a:lnB>
+                    <a:solidFill>
+                      <a:srgbClr val="4285F4"/>
+                    </a:solidFill>
+                  </a:tcPr>
+                </a:tc>
+                <a:tc>
+                  <a:txBody>
+                    <a:bodyPr/>
+                    <a:lstStyle/>
+                    <a:p>
+                      <a:pPr indent="0" marL="0">
+                        <a:buNone/>
+                      </a:pPr>
+                      <a:r>
+                        <a:rPr lang="en-US" sz="850" b="1" dirty="0">
+                          <a:solidFill>
+                            <a:srgbClr val="FFFFFF"/>
+                          </a:solidFill>
+                          <a:latin typeface="Google Sans" pitchFamily="34" charset="0"/>
+                          <a:ea typeface="Google Sans" pitchFamily="34" charset="-122"/>
+                          <a:cs typeface="Google Sans" pitchFamily="34" charset="-120"/>
+                        </a:rPr>
+                        <a:t>Naive Shared Multi-Tenancy (Anti-Pattern)</a:t>
+                      </a:r>
+                      <a:endParaRPr lang="en-US" sz="850" dirty="0">
+                        <a:latin typeface="Google Sans" charset="0"/>
+                        <a:ea typeface="Google Sans" charset="0"/>
+                        <a:cs typeface="Google Sans" charset="0"/>
+                      </a:endParaRPr>
+                    </a:p>
+                  </a:txBody>
+                  <a:tcPr marL="91440" marR="91440" marT="45720" marB="45720" anchor="ctr">
+                    <a:lnL w="9525" cap="flat" cmpd="sng" algn="ctr">
+                      <a:solidFill>
+                        <a:srgbClr val="DADCE0"/>
+                      </a:solidFill>
+                      <a:prstDash val="solid"/>
+                      <a:round/>
+                      <a:headEnd type="none" w="med" len="med"/>
+                      <a:tailEnd type="none" w="med" len="med"/>
+                    </a:lnL>
+                    <a:lnR w="9525" cap="flat" cmpd="sng" algn="ctr">
+                      <a:solidFill>
+                        <a:srgbClr val="DADCE0"/>
+                      </a:solidFill>
+                      <a:prstDash val="solid"/>
+                      <a:round/>
+                      <a:headEnd type="none" w="med" len="med"/>
+                      <a:tailEnd type="none" w="med" len="med"/>
+                    </a:lnR>
+                    <a:lnT w="9525" cap="flat" cmpd="sng" algn="ctr">
+                      <a:solidFill>
+                        <a:srgbClr val="DADCE0"/>
+                      </a:solidFill>
+                      <a:prstDash val="solid"/>
+                      <a:round/>
+                      <a:headEnd type="none" w="med" len="med"/>
+                      <a:tailEnd type="none" w="med" len="med"/>
+                    </a:lnT>
+                    <a:lnB w="9525" cap="flat" cmpd="sng" algn="ctr">
+                      <a:solidFill>
+                        <a:srgbClr val="DADCE0"/>
+                      </a:solidFill>
+                      <a:prstDash val="solid"/>
+                      <a:round/>
+                      <a:headEnd type="none" w="med" len="med"/>
+                      <a:tailEnd type="none" w="med" len="med"/>
+                    </a:lnB>
+                    <a:solidFill>
+                      <a:srgbClr val="4285F4"/>
+                    </a:solidFill>
+                  </a:tcPr>
+                </a:tc>
+                <a:tc>
+                  <a:txBody>
+                    <a:bodyPr/>
+                    <a:lstStyle/>
+                    <a:p>
+                      <a:pPr indent="0" marL="0">
+                        <a:buNone/>
+                      </a:pPr>
+                      <a:r>
+                        <a:rPr lang="en-US" sz="850" b="1" dirty="0">
+                          <a:solidFill>
+                            <a:srgbClr val="FFFFFF"/>
+                          </a:solidFill>
+                          <a:latin typeface="Google Sans" pitchFamily="34" charset="0"/>
+                          <a:ea typeface="Google Sans" pitchFamily="34" charset="-122"/>
+                          <a:cs typeface="Google Sans" pitchFamily="34" charset="-120"/>
+                        </a:rPr>
+                        <a:t>Pattern A: Cryptographic Pooled (WS2 Target)</a:t>
+                      </a:r>
+                      <a:endParaRPr lang="en-US" sz="850" dirty="0">
+                        <a:latin typeface="Google Sans" charset="0"/>
+                        <a:ea typeface="Google Sans" charset="0"/>
+                        <a:cs typeface="Google Sans" charset="0"/>
+                      </a:endParaRPr>
+                    </a:p>
+                  </a:txBody>
+                  <a:tcPr marL="91440" marR="91440" marT="45720" marB="45720" anchor="ctr">
+                    <a:lnL w="9525" cap="flat" cmpd="sng" algn="ctr">
+                      <a:solidFill>
+                        <a:srgbClr val="DADCE0"/>
+                      </a:solidFill>
+                      <a:prstDash val="solid"/>
+                      <a:round/>
+                      <a:headEnd type="none" w="med" len="med"/>
+                      <a:tailEnd type="none" w="med" len="med"/>
+                    </a:lnL>
+                    <a:lnR w="9525" cap="flat" cmpd="sng" algn="ctr">
+                      <a:solidFill>
+                        <a:srgbClr val="DADCE0"/>
+                      </a:solidFill>
+                      <a:prstDash val="solid"/>
+                      <a:round/>
+                      <a:headEnd type="none" w="med" len="med"/>
+                      <a:tailEnd type="none" w="med" len="med"/>
+                    </a:lnR>
+                    <a:lnT w="9525" cap="flat" cmpd="sng" algn="ctr">
+                      <a:solidFill>
+                        <a:srgbClr val="DADCE0"/>
+                      </a:solidFill>
+                      <a:prstDash val="solid"/>
+                      <a:round/>
+                      <a:headEnd type="none" w="med" len="med"/>
+                      <a:tailEnd type="none" w="med" len="med"/>
+                    </a:lnT>
+                    <a:lnB w="9525" cap="flat" cmpd="sng" algn="ctr">
+                      <a:solidFill>
+                        <a:srgbClr val="DADCE0"/>
+                      </a:solidFill>
+                      <a:prstDash val="solid"/>
+                      <a:round/>
+                      <a:headEnd type="none" w="med" len="med"/>
+                      <a:tailEnd type="none" w="med" len="med"/>
+                    </a:lnB>
+                    <a:solidFill>
+                      <a:srgbClr val="4285F4"/>
+                    </a:solidFill>
+                  </a:tcPr>
+                </a:tc>
+                <a:tc>
+                  <a:txBody>
+                    <a:bodyPr/>
+                    <a:lstStyle/>
+                    <a:p>
+                      <a:pPr indent="0" marL="0">
+                        <a:buNone/>
+                      </a:pPr>
+                      <a:r>
+                        <a:rPr lang="en-US" sz="850" b="1" dirty="0">
+                          <a:solidFill>
+                            <a:srgbClr val="FFFFFF"/>
+                          </a:solidFill>
+                          <a:latin typeface="Google Sans" pitchFamily="34" charset="0"/>
+                          <a:ea typeface="Google Sans" pitchFamily="34" charset="-122"/>
+                          <a:cs typeface="Google Sans" pitchFamily="34" charset="-120"/>
+                        </a:rPr>
+                        <a:t>Pattern B: Dedicated Sovereign Silos (WS3)</a:t>
+                      </a:r>
+                      <a:endParaRPr lang="en-US" sz="850" dirty="0">
+                        <a:latin typeface="Google Sans" charset="0"/>
+                        <a:ea typeface="Google Sans" charset="0"/>
+                        <a:cs typeface="Google Sans" charset="0"/>
+                      </a:endParaRPr>
+                    </a:p>
+                  </a:txBody>
+                  <a:tcPr marL="91440" marR="91440" marT="45720" marB="45720" anchor="ctr">
+                    <a:lnL w="9525" cap="flat" cmpd="sng" algn="ctr">
+                      <a:solidFill>
+                        <a:srgbClr val="DADCE0"/>
+                      </a:solidFill>
+                      <a:prstDash val="solid"/>
+                      <a:round/>
+                      <a:headEnd type="none" w="med" len="med"/>
+                      <a:tailEnd type="none" w="med" len="med"/>
+                    </a:lnL>
+                    <a:lnR w="9525" cap="flat" cmpd="sng" algn="ctr">
+                      <a:solidFill>
+                        <a:srgbClr val="DADCE0"/>
+                      </a:solidFill>
+                      <a:prstDash val="solid"/>
+                      <a:round/>
+                      <a:headEnd type="none" w="med" len="med"/>
+                      <a:tailEnd type="none" w="med" len="med"/>
+                    </a:lnR>
+                    <a:lnT w="9525" cap="flat" cmpd="sng" algn="ctr">
+                      <a:solidFill>
+                        <a:srgbClr val="DADCE0"/>
+                      </a:solidFill>
+                      <a:prstDash val="solid"/>
+                      <a:round/>
+                      <a:headEnd type="none" w="med" len="med"/>
+                      <a:tailEnd type="none" w="med" len="med"/>
+                    </a:lnT>
+                    <a:lnB w="9525" cap="flat" cmpd="sng" algn="ctr">
+                      <a:solidFill>
+                        <a:srgbClr val="DADCE0"/>
+                      </a:solidFill>
+                      <a:prstDash val="solid"/>
+                      <a:round/>
+                      <a:headEnd type="none" w="med" len="med"/>
+                      <a:tailEnd type="none" w="med" len="med"/>
+                    </a:lnB>
+                    <a:solidFill>
+                      <a:srgbClr val="4285F4"/>
+                    </a:solidFill>
+                  </a:tcPr>
+                </a:tc>
+              </a:tr>
+              <a:tr h="0">
+                <a:tc>
+                  <a:txBody>
+                    <a:bodyPr/>
+                    <a:lstStyle/>
+                    <a:p>
+                      <a:pPr indent="0" marL="0">
+                        <a:buNone/>
+                      </a:pPr>
+                      <a:r>
+                        <a:rPr lang="en-US" sz="780" b="1" dirty="0">
+                          <a:solidFill>
+                            <a:srgbClr val="3C4043"/>
+                          </a:solidFill>
+                          <a:latin typeface="Google Sans" pitchFamily="34" charset="0"/>
+                          <a:ea typeface="Google Sans" pitchFamily="34" charset="-122"/>
+                          <a:cs typeface="Google Sans" pitchFamily="34" charset="-120"/>
+                        </a:rPr>
+                        <a:t>Ingress &amp; identity binding</a:t>
+                      </a:r>
+                      <a:endParaRPr lang="en-US" sz="780" dirty="0">
+                        <a:latin typeface="Google Sans" charset="0"/>
+                        <a:ea typeface="Google Sans" charset="0"/>
+                        <a:cs typeface="Google Sans" charset="0"/>
+                      </a:endParaRPr>
+                    </a:p>
+                  </a:txBody>
+                  <a:tcPr marL="91440" marR="91440" marT="45720" marB="45720" anchor="ctr">
+                    <a:lnL w="9525" cap="flat" cmpd="sng" algn="ctr">
+                      <a:solidFill>
+                        <a:srgbClr val="DADCE0"/>
+                      </a:solidFill>
+                      <a:prstDash val="solid"/>
+                      <a:round/>
+                      <a:headEnd type="none" w="med" len="med"/>
+                      <a:tailEnd type="none" w="med" len="med"/>
+                    </a:lnL>
+                    <a:lnR w="9525" cap="flat" cmpd="sng" algn="ctr">
+                      <a:solidFill>
+                        <a:srgbClr val="DADCE0"/>
+                      </a:solidFill>
+                      <a:prstDash val="solid"/>
+                      <a:round/>
+                      <a:headEnd type="none" w="med" len="med"/>
+                      <a:tailEnd type="none" w="med" len="med"/>
+                    </a:lnR>
+                    <a:lnT w="9525" cap="flat" cmpd="sng" algn="ctr">
+                      <a:solidFill>
+                        <a:srgbClr val="DADCE0"/>
+                      </a:solidFill>
+                      <a:prstDash val="solid"/>
+                      <a:round/>
+                      <a:headEnd type="none" w="med" len="med"/>
+                      <a:tailEnd type="none" w="med" len="med"/>
+                    </a:lnT>
+                    <a:lnB w="9525" cap="flat" cmpd="sng" algn="ctr">
+                      <a:solidFill>
+                        <a:srgbClr val="DADCE0"/>
+                      </a:solidFill>
+                      <a:prstDash val="solid"/>
+                      <a:round/>
+                      <a:headEnd type="none" w="med" len="med"/>
+                      <a:tailEnd type="none" w="med" len="med"/>
+                    </a:lnB>
+                    <a:solidFill>
+                      <a:srgbClr val="FFFFFF"/>
+                    </a:solidFill>
+                  </a:tcPr>
+                </a:tc>
+                <a:tc>
+                  <a:txBody>
+                    <a:bodyPr/>
+                    <a:lstStyle/>
+                    <a:p>
+                      <a:pPr indent="0" marL="0">
+                        <a:buNone/>
+                      </a:pPr>
+                      <a:r>
+                        <a:rPr lang="en-US" sz="760" dirty="0">
+                          <a:solidFill>
+                            <a:srgbClr val="5F6368"/>
+                          </a:solidFill>
+                          <a:latin typeface="Roboto" pitchFamily="34" charset="0"/>
+                          <a:ea typeface="Roboto" pitchFamily="34" charset="-122"/>
+                          <a:cs typeface="Roboto" pitchFamily="34" charset="-120"/>
+                        </a:rPr>
+                        <a:t>Trusts client-supplied X-Tenant-Id HTTP header or shared API key in application code</a:t>
+                      </a:r>
+                      <a:endParaRPr lang="en-US" sz="760" dirty="0">
+                        <a:latin typeface="Roboto" charset="0"/>
+                        <a:ea typeface="Roboto" charset="0"/>
+                        <a:cs typeface="Roboto" charset="0"/>
+                      </a:endParaRPr>
+                    </a:p>
+                  </a:txBody>
+                  <a:tcPr marL="91440" marR="91440" marT="45720" marB="45720" anchor="ctr">
+                    <a:lnL w="9525" cap="flat" cmpd="sng" algn="ctr">
+                      <a:solidFill>
+                        <a:srgbClr val="DADCE0"/>
+                      </a:solidFill>
+                      <a:prstDash val="solid"/>
+                      <a:round/>
+                      <a:headEnd type="none" w="med" len="med"/>
+                      <a:tailEnd type="none" w="med" len="med"/>
+                    </a:lnL>
+                    <a:lnR w="9525" cap="flat" cmpd="sng" algn="ctr">
+                      <a:solidFill>
+                        <a:srgbClr val="DADCE0"/>
+                      </a:solidFill>
+                      <a:prstDash val="solid"/>
+                      <a:round/>
+                      <a:headEnd type="none" w="med" len="med"/>
+                      <a:tailEnd type="none" w="med" len="med"/>
+                    </a:lnR>
+                    <a:lnT w="9525" cap="flat" cmpd="sng" algn="ctr">
+                      <a:solidFill>
+                        <a:srgbClr val="DADCE0"/>
+                      </a:solidFill>
+                      <a:prstDash val="solid"/>
+                      <a:round/>
+                      <a:headEnd type="none" w="med" len="med"/>
+                      <a:tailEnd type="none" w="med" len="med"/>
+                    </a:lnT>
+                    <a:lnB w="9525" cap="flat" cmpd="sng" algn="ctr">
+                      <a:solidFill>
+                        <a:srgbClr val="DADCE0"/>
+                      </a:solidFill>
+                      <a:prstDash val="solid"/>
+                      <a:round/>
+                      <a:headEnd type="none" w="med" len="med"/>
+                      <a:tailEnd type="none" w="med" len="med"/>
+                    </a:lnB>
+                    <a:solidFill>
+                      <a:srgbClr val="FFFFFF"/>
+                    </a:solidFill>
+                  </a:tcPr>
+                </a:tc>
+                <a:tc>
+                  <a:txBody>
+                    <a:bodyPr/>
+                    <a:lstStyle/>
+                    <a:p>
+                      <a:pPr indent="0" marL="0">
+                        <a:buNone/>
+                      </a:pPr>
+                      <a:r>
+                        <a:rPr lang="en-US" sz="760" dirty="0">
+                          <a:solidFill>
+                            <a:srgbClr val="5F6368"/>
+                          </a:solidFill>
+                          <a:latin typeface="Roboto" pitchFamily="34" charset="0"/>
+                          <a:ea typeface="Roboto" pitchFamily="34" charset="-122"/>
+                          <a:cs typeface="Roboto" pitchFamily="34" charset="-120"/>
+                        </a:rPr>
+                        <a:t>Cloud Armor strips X-Tenant-Id; IAP + STS mints RFC 8693 OBO &amp; RFC 9449 DPoP context</a:t>
+                      </a:r>
+                      <a:endParaRPr lang="en-US" sz="760" dirty="0">
+                        <a:latin typeface="Roboto" charset="0"/>
+                        <a:ea typeface="Roboto" charset="0"/>
+                        <a:cs typeface="Roboto" charset="0"/>
+                      </a:endParaRPr>
+                    </a:p>
+                  </a:txBody>
+                  <a:tcPr marL="91440" marR="91440" marT="45720" marB="45720" anchor="ctr">
+                    <a:lnL w="9525" cap="flat" cmpd="sng" algn="ctr">
+                      <a:solidFill>
+                        <a:srgbClr val="DADCE0"/>
+                      </a:solidFill>
+                      <a:prstDash val="solid"/>
+                      <a:round/>
+                      <a:headEnd type="none" w="med" len="med"/>
+                      <a:tailEnd type="none" w="med" len="med"/>
+                    </a:lnL>
+                    <a:lnR w="9525" cap="flat" cmpd="sng" algn="ctr">
+                      <a:solidFill>
+                        <a:srgbClr val="DADCE0"/>
+                      </a:solidFill>
+                      <a:prstDash val="solid"/>
+                      <a:round/>
+                      <a:headEnd type="none" w="med" len="med"/>
+                      <a:tailEnd type="none" w="med" len="med"/>
+                    </a:lnR>
+                    <a:lnT w="9525" cap="flat" cmpd="sng" algn="ctr">
+                      <a:solidFill>
+                        <a:srgbClr val="DADCE0"/>
+                      </a:solidFill>
+                      <a:prstDash val="solid"/>
+                      <a:round/>
+                      <a:headEnd type="none" w="med" len="med"/>
+                      <a:tailEnd type="none" w="med" len="med"/>
+                    </a:lnT>
+                    <a:lnB w="9525" cap="flat" cmpd="sng" algn="ctr">
+                      <a:solidFill>
+                        <a:srgbClr val="DADCE0"/>
+                      </a:solidFill>
+                      <a:prstDash val="solid"/>
+                      <a:round/>
+                      <a:headEnd type="none" w="med" len="med"/>
+                      <a:tailEnd type="none" w="med" len="med"/>
+                    </a:lnB>
+                    <a:solidFill>
+                      <a:srgbClr val="FFFFFF"/>
+                    </a:solidFill>
+                  </a:tcPr>
+                </a:tc>
+                <a:tc>
+                  <a:txBody>
+                    <a:bodyPr/>
+                    <a:lstStyle/>
+                    <a:p>
+                      <a:pPr indent="0" marL="0">
+                        <a:buNone/>
+                      </a:pPr>
+                      <a:r>
+                        <a:rPr lang="en-US" sz="760" dirty="0">
+                          <a:solidFill>
+                            <a:srgbClr val="5F6368"/>
+                          </a:solidFill>
+                          <a:latin typeface="Roboto" pitchFamily="34" charset="0"/>
+                          <a:ea typeface="Roboto" pitchFamily="34" charset="-122"/>
+                          <a:cs typeface="Roboto" pitchFamily="34" charset="-120"/>
+                        </a:rPr>
+                        <a:t>BeyondCorp mTLS cert pinning + per-project IAM Principal Access Boundary (PAB)</a:t>
+                      </a:r>
+                      <a:endParaRPr lang="en-US" sz="760" dirty="0">
+                        <a:latin typeface="Roboto" charset="0"/>
+                        <a:ea typeface="Roboto" charset="0"/>
+                        <a:cs typeface="Roboto" charset="0"/>
+                      </a:endParaRPr>
+                    </a:p>
+                  </a:txBody>
+                  <a:tcPr marL="91440" marR="91440" marT="45720" marB="45720" anchor="ctr">
+                    <a:lnL w="9525" cap="flat" cmpd="sng" algn="ctr">
+                      <a:solidFill>
+                        <a:srgbClr val="DADCE0"/>
+                      </a:solidFill>
+                      <a:prstDash val="solid"/>
+                      <a:round/>
+                      <a:headEnd type="none" w="med" len="med"/>
+                      <a:tailEnd type="none" w="med" len="med"/>
+                    </a:lnL>
+                    <a:lnR w="9525" cap="flat" cmpd="sng" algn="ctr">
+                      <a:solidFill>
+                        <a:srgbClr val="DADCE0"/>
+                      </a:solidFill>
+                      <a:prstDash val="solid"/>
+                      <a:round/>
+                      <a:headEnd type="none" w="med" len="med"/>
+                      <a:tailEnd type="none" w="med" len="med"/>
+                    </a:lnR>
+                    <a:lnT w="9525" cap="flat" cmpd="sng" algn="ctr">
+                      <a:solidFill>
+                        <a:srgbClr val="DADCE0"/>
+                      </a:solidFill>
+                      <a:prstDash val="solid"/>
+                      <a:round/>
+                      <a:headEnd type="none" w="med" len="med"/>
+                      <a:tailEnd type="none" w="med" len="med"/>
+                    </a:lnT>
+                    <a:lnB w="9525" cap="flat" cmpd="sng" algn="ctr">
+                      <a:solidFill>
+                        <a:srgbClr val="DADCE0"/>
+                      </a:solidFill>
+                      <a:prstDash val="solid"/>
+                      <a:round/>
+                      <a:headEnd type="none" w="med" len="med"/>
+                      <a:tailEnd type="none" w="med" len="med"/>
+                    </a:lnB>
+                    <a:solidFill>
+                      <a:srgbClr val="FFFFFF"/>
+                    </a:solidFill>
+                  </a:tcPr>
+                </a:tc>
+              </a:tr>
+              <a:tr h="0">
+                <a:tc>
+                  <a:txBody>
+                    <a:bodyPr/>
+                    <a:lstStyle/>
+                    <a:p>
+                      <a:pPr indent="0" marL="0">
+                        <a:buNone/>
+                      </a:pPr>
+                      <a:r>
+                        <a:rPr lang="en-US" sz="780" b="1" dirty="0">
+                          <a:solidFill>
+                            <a:srgbClr val="3C4043"/>
+                          </a:solidFill>
+                          <a:latin typeface="Google Sans" pitchFamily="34" charset="0"/>
+                          <a:ea typeface="Google Sans" pitchFamily="34" charset="-122"/>
+                          <a:cs typeface="Google Sans" pitchFamily="34" charset="-120"/>
+                        </a:rPr>
+                        <a:t>Tool catalog &amp; memory state</a:t>
+                      </a:r>
+                      <a:endParaRPr lang="en-US" sz="780" dirty="0">
+                        <a:latin typeface="Google Sans" charset="0"/>
+                        <a:ea typeface="Google Sans" charset="0"/>
+                        <a:cs typeface="Google Sans" charset="0"/>
+                      </a:endParaRPr>
+                    </a:p>
+                  </a:txBody>
+                  <a:tcPr marL="91440" marR="91440" marT="45720" marB="45720" anchor="ctr">
+                    <a:lnL w="9525" cap="flat" cmpd="sng" algn="ctr">
+                      <a:solidFill>
+                        <a:srgbClr val="DADCE0"/>
+                      </a:solidFill>
+                      <a:prstDash val="solid"/>
+                      <a:round/>
+                      <a:headEnd type="none" w="med" len="med"/>
+                      <a:tailEnd type="none" w="med" len="med"/>
+                    </a:lnL>
+                    <a:lnR w="9525" cap="flat" cmpd="sng" algn="ctr">
+                      <a:solidFill>
+                        <a:srgbClr val="DADCE0"/>
+                      </a:solidFill>
+                      <a:prstDash val="solid"/>
+                      <a:round/>
+                      <a:headEnd type="none" w="med" len="med"/>
+                      <a:tailEnd type="none" w="med" len="med"/>
+                    </a:lnR>
+                    <a:lnT w="9525" cap="flat" cmpd="sng" algn="ctr">
+                      <a:solidFill>
+                        <a:srgbClr val="DADCE0"/>
+                      </a:solidFill>
+                      <a:prstDash val="solid"/>
+                      <a:round/>
+                      <a:headEnd type="none" w="med" len="med"/>
+                      <a:tailEnd type="none" w="med" len="med"/>
+                    </a:lnT>
+                    <a:lnB w="9525" cap="flat" cmpd="sng" algn="ctr">
+                      <a:solidFill>
+                        <a:srgbClr val="DADCE0"/>
+                      </a:solidFill>
+                      <a:prstDash val="solid"/>
+                      <a:round/>
+                      <a:headEnd type="none" w="med" len="med"/>
+                      <a:tailEnd type="none" w="med" len="med"/>
+                    </a:lnB>
+                    <a:solidFill>
+                      <a:srgbClr val="F8F9FA"/>
+                    </a:solidFill>
+                  </a:tcPr>
+                </a:tc>
+                <a:tc>
+                  <a:txBody>
+                    <a:bodyPr/>
+                    <a:lstStyle/>
+                    <a:p>
+                      <a:pPr indent="0" marL="0">
+                        <a:buNone/>
+                      </a:pPr>
+                      <a:r>
+                        <a:rPr lang="en-US" sz="760" dirty="0">
+                          <a:solidFill>
+                            <a:srgbClr val="5F6368"/>
+                          </a:solidFill>
+                          <a:latin typeface="Roboto" pitchFamily="34" charset="0"/>
+                          <a:ea typeface="Roboto" pitchFamily="34" charset="-122"/>
+                          <a:cs typeface="Roboto" pitchFamily="34" charset="-120"/>
+                        </a:rPr>
+                        <a:t>Global MCP tool list &amp; shared vector collection accessible to any prompt</a:t>
+                      </a:r>
+                      <a:endParaRPr lang="en-US" sz="760" dirty="0">
+                        <a:latin typeface="Roboto" charset="0"/>
+                        <a:ea typeface="Roboto" charset="0"/>
+                        <a:cs typeface="Roboto" charset="0"/>
+                      </a:endParaRPr>
+                    </a:p>
+                  </a:txBody>
+                  <a:tcPr marL="91440" marR="91440" marT="45720" marB="45720" anchor="ctr">
+                    <a:lnL w="9525" cap="flat" cmpd="sng" algn="ctr">
+                      <a:solidFill>
+                        <a:srgbClr val="DADCE0"/>
+                      </a:solidFill>
+                      <a:prstDash val="solid"/>
+                      <a:round/>
+                      <a:headEnd type="none" w="med" len="med"/>
+                      <a:tailEnd type="none" w="med" len="med"/>
+                    </a:lnL>
+                    <a:lnR w="9525" cap="flat" cmpd="sng" algn="ctr">
+                      <a:solidFill>
+                        <a:srgbClr val="DADCE0"/>
+                      </a:solidFill>
+                      <a:prstDash val="solid"/>
+                      <a:round/>
+                      <a:headEnd type="none" w="med" len="med"/>
+                      <a:tailEnd type="none" w="med" len="med"/>
+                    </a:lnR>
+                    <a:lnT w="9525" cap="flat" cmpd="sng" algn="ctr">
+                      <a:solidFill>
+                        <a:srgbClr val="DADCE0"/>
+                      </a:solidFill>
+                      <a:prstDash val="solid"/>
+                      <a:round/>
+                      <a:headEnd type="none" w="med" len="med"/>
+                      <a:tailEnd type="none" w="med" len="med"/>
+                    </a:lnT>
+                    <a:lnB w="9525" cap="flat" cmpd="sng" algn="ctr">
+                      <a:solidFill>
+                        <a:srgbClr val="DADCE0"/>
+                      </a:solidFill>
+                      <a:prstDash val="solid"/>
+                      <a:round/>
+                      <a:headEnd type="none" w="med" len="med"/>
+                      <a:tailEnd type="none" w="med" len="med"/>
+                    </a:lnB>
+                    <a:solidFill>
+                      <a:srgbClr val="F8F9FA"/>
+                    </a:solidFill>
+                  </a:tcPr>
+                </a:tc>
+                <a:tc>
+                  <a:txBody>
+                    <a:bodyPr/>
+                    <a:lstStyle/>
+                    <a:p>
+                      <a:pPr indent="0" marL="0">
+                        <a:buNone/>
+                      </a:pPr>
+                      <a:r>
+                        <a:rPr lang="en-US" sz="760" dirty="0">
+                          <a:solidFill>
+                            <a:srgbClr val="5F6368"/>
+                          </a:solidFill>
+                          <a:latin typeface="Roboto" pitchFamily="34" charset="0"/>
+                          <a:ea typeface="Roboto" pitchFamily="34" charset="-122"/>
+                          <a:cs typeface="Roboto" pitchFamily="34" charset="-120"/>
+                        </a:rPr>
+                        <a:t>Hop 2 ARD visibility filter (HTTP 403) + mem://{tenant_id}/L1..L5 namespace isolation</a:t>
+                      </a:r>
+                      <a:endParaRPr lang="en-US" sz="760" dirty="0">
+                        <a:latin typeface="Roboto" charset="0"/>
+                        <a:ea typeface="Roboto" charset="0"/>
+                        <a:cs typeface="Roboto" charset="0"/>
+                      </a:endParaRPr>
+                    </a:p>
+                  </a:txBody>
+                  <a:tcPr marL="91440" marR="91440" marT="45720" marB="45720" anchor="ctr">
+                    <a:lnL w="9525" cap="flat" cmpd="sng" algn="ctr">
+                      <a:solidFill>
+                        <a:srgbClr val="DADCE0"/>
+                      </a:solidFill>
+                      <a:prstDash val="solid"/>
+                      <a:round/>
+                      <a:headEnd type="none" w="med" len="med"/>
+                      <a:tailEnd type="none" w="med" len="med"/>
+                    </a:lnL>
+                    <a:lnR w="9525" cap="flat" cmpd="sng" algn="ctr">
+                      <a:solidFill>
+                        <a:srgbClr val="DADCE0"/>
+                      </a:solidFill>
+                      <a:prstDash val="solid"/>
+                      <a:round/>
+                      <a:headEnd type="none" w="med" len="med"/>
+                      <a:tailEnd type="none" w="med" len="med"/>
+                    </a:lnR>
+                    <a:lnT w="9525" cap="flat" cmpd="sng" algn="ctr">
+                      <a:solidFill>
+                        <a:srgbClr val="DADCE0"/>
+                      </a:solidFill>
+                      <a:prstDash val="solid"/>
+                      <a:round/>
+                      <a:headEnd type="none" w="med" len="med"/>
+                      <a:tailEnd type="none" w="med" len="med"/>
+                    </a:lnT>
+                    <a:lnB w="9525" cap="flat" cmpd="sng" algn="ctr">
+                      <a:solidFill>
+                        <a:srgbClr val="DADCE0"/>
+                      </a:solidFill>
+                      <a:prstDash val="solid"/>
+                      <a:round/>
+                      <a:headEnd type="none" w="med" len="med"/>
+                      <a:tailEnd type="none" w="med" len="med"/>
+                    </a:lnB>
+                    <a:solidFill>
+                      <a:srgbClr val="F8F9FA"/>
+                    </a:solidFill>
+                  </a:tcPr>
+                </a:tc>
+                <a:tc>
+                  <a:txBody>
+                    <a:bodyPr/>
+                    <a:lstStyle/>
+                    <a:p>
+                      <a:pPr indent="0" marL="0">
+                        <a:buNone/>
+                      </a:pPr>
+                      <a:r>
+                        <a:rPr lang="en-US" sz="760" dirty="0">
+                          <a:solidFill>
+                            <a:srgbClr val="5F6368"/>
+                          </a:solidFill>
+                          <a:latin typeface="Roboto" pitchFamily="34" charset="0"/>
+                          <a:ea typeface="Roboto" pitchFamily="34" charset="-122"/>
+                          <a:cs typeface="Roboto" pitchFamily="34" charset="-120"/>
+                        </a:rPr>
+                        <a:t>Physical per-project Agent Engine Registry &amp; CMEK-encrypted Memory Bank</a:t>
+                      </a:r>
+                      <a:endParaRPr lang="en-US" sz="760" dirty="0">
+                        <a:latin typeface="Roboto" charset="0"/>
+                        <a:ea typeface="Roboto" charset="0"/>
+                        <a:cs typeface="Roboto" charset="0"/>
+                      </a:endParaRPr>
+                    </a:p>
+                  </a:txBody>
+                  <a:tcPr marL="91440" marR="91440" marT="45720" marB="45720" anchor="ctr">
+                    <a:lnL w="9525" cap="flat" cmpd="sng" algn="ctr">
+                      <a:solidFill>
+                        <a:srgbClr val="DADCE0"/>
+                      </a:solidFill>
+                      <a:prstDash val="solid"/>
+                      <a:round/>
+                      <a:headEnd type="none" w="med" len="med"/>
+                      <a:tailEnd type="none" w="med" len="med"/>
+                    </a:lnL>
+                    <a:lnR w="9525" cap="flat" cmpd="sng" algn="ctr">
+                      <a:solidFill>
+                        <a:srgbClr val="DADCE0"/>
+                      </a:solidFill>
+                      <a:prstDash val="solid"/>
+                      <a:round/>
+                      <a:headEnd type="none" w="med" len="med"/>
+                      <a:tailEnd type="none" w="med" len="med"/>
+                    </a:lnR>
+                    <a:lnT w="9525" cap="flat" cmpd="sng" algn="ctr">
+                      <a:solidFill>
+                        <a:srgbClr val="DADCE0"/>
+                      </a:solidFill>
+                      <a:prstDash val="solid"/>
+                      <a:round/>
+                      <a:headEnd type="none" w="med" len="med"/>
+                      <a:tailEnd type="none" w="med" len="med"/>
+                    </a:lnT>
+                    <a:lnB w="9525" cap="flat" cmpd="sng" algn="ctr">
+                      <a:solidFill>
+                        <a:srgbClr val="DADCE0"/>
+                      </a:solidFill>
+                      <a:prstDash val="solid"/>
+                      <a:round/>
+                      <a:headEnd type="none" w="med" len="med"/>
+                      <a:tailEnd type="none" w="med" len="med"/>
+                    </a:lnB>
+                    <a:solidFill>
+                      <a:srgbClr val="F8F9FA"/>
+                    </a:solidFill>
+                  </a:tcPr>
+                </a:tc>
+              </a:tr>
+              <a:tr h="0">
+                <a:tc>
+                  <a:txBody>
+                    <a:bodyPr/>
+                    <a:lstStyle/>
+                    <a:p>
+                      <a:pPr indent="0" marL="0">
+                        <a:buNone/>
+                      </a:pPr>
+                      <a:r>
+                        <a:rPr lang="en-US" sz="780" b="1" dirty="0">
+                          <a:solidFill>
+                            <a:srgbClr val="3C4043"/>
+                          </a:solidFill>
+                          <a:latin typeface="Google Sans" pitchFamily="34" charset="0"/>
+                          <a:ea typeface="Google Sans" pitchFamily="34" charset="-122"/>
+                          <a:cs typeface="Google Sans" pitchFamily="34" charset="-120"/>
+                        </a:rPr>
+                        <a:t>Rate limits &amp; reasoning quotas</a:t>
+                      </a:r>
+                      <a:endParaRPr lang="en-US" sz="780" dirty="0">
+                        <a:latin typeface="Google Sans" charset="0"/>
+                        <a:ea typeface="Google Sans" charset="0"/>
+                        <a:cs typeface="Google Sans" charset="0"/>
+                      </a:endParaRPr>
+                    </a:p>
+                  </a:txBody>
+                  <a:tcPr marL="91440" marR="91440" marT="45720" marB="45720" anchor="ctr">
+                    <a:lnL w="9525" cap="flat" cmpd="sng" algn="ctr">
+                      <a:solidFill>
+                        <a:srgbClr val="DADCE0"/>
+                      </a:solidFill>
+                      <a:prstDash val="solid"/>
+                      <a:round/>
+                      <a:headEnd type="none" w="med" len="med"/>
+                      <a:tailEnd type="none" w="med" len="med"/>
+                    </a:lnL>
+                    <a:lnR w="9525" cap="flat" cmpd="sng" algn="ctr">
+                      <a:solidFill>
+                        <a:srgbClr val="DADCE0"/>
+                      </a:solidFill>
+                      <a:prstDash val="solid"/>
+                      <a:round/>
+                      <a:headEnd type="none" w="med" len="med"/>
+                      <a:tailEnd type="none" w="med" len="med"/>
+                    </a:lnR>
+                    <a:lnT w="9525" cap="flat" cmpd="sng" algn="ctr">
+                      <a:solidFill>
+                        <a:srgbClr val="DADCE0"/>
+                      </a:solidFill>
+                      <a:prstDash val="solid"/>
+                      <a:round/>
+                      <a:headEnd type="none" w="med" len="med"/>
+                      <a:tailEnd type="none" w="med" len="med"/>
+                    </a:lnT>
+                    <a:lnB w="9525" cap="flat" cmpd="sng" algn="ctr">
+                      <a:solidFill>
+                        <a:srgbClr val="DADCE0"/>
+                      </a:solidFill>
+                      <a:prstDash val="solid"/>
+                      <a:round/>
+                      <a:headEnd type="none" w="med" len="med"/>
+                      <a:tailEnd type="none" w="med" len="med"/>
+                    </a:lnB>
+                    <a:solidFill>
+                      <a:srgbClr val="FFFFFF"/>
+                    </a:solidFill>
+                  </a:tcPr>
+                </a:tc>
+                <a:tc>
+                  <a:txBody>
+                    <a:bodyPr/>
+                    <a:lstStyle/>
+                    <a:p>
+                      <a:pPr indent="0" marL="0">
+                        <a:buNone/>
+                      </a:pPr>
+                      <a:r>
+                        <a:rPr lang="en-US" sz="760" dirty="0">
+                          <a:solidFill>
+                            <a:srgbClr val="5F6368"/>
+                          </a:solidFill>
+                          <a:latin typeface="Roboto" pitchFamily="34" charset="0"/>
+                          <a:ea typeface="Roboto" pitchFamily="34" charset="-122"/>
+                          <a:cs typeface="Roboto" pitchFamily="34" charset="-120"/>
+                        </a:rPr>
+                        <a:t>Regional Vertex AI RPM/TPM shared first-come, first-served (noisy-neighbor outages)</a:t>
+                      </a:r>
+                      <a:endParaRPr lang="en-US" sz="760" dirty="0">
+                        <a:latin typeface="Roboto" charset="0"/>
+                        <a:ea typeface="Roboto" charset="0"/>
+                        <a:cs typeface="Roboto" charset="0"/>
+                      </a:endParaRPr>
+                    </a:p>
+                  </a:txBody>
+                  <a:tcPr marL="91440" marR="91440" marT="45720" marB="45720" anchor="ctr">
+                    <a:lnL w="9525" cap="flat" cmpd="sng" algn="ctr">
+                      <a:solidFill>
+                        <a:srgbClr val="DADCE0"/>
+                      </a:solidFill>
+                      <a:prstDash val="solid"/>
+                      <a:round/>
+                      <a:headEnd type="none" w="med" len="med"/>
+                      <a:tailEnd type="none" w="med" len="med"/>
+                    </a:lnL>
+                    <a:lnR w="9525" cap="flat" cmpd="sng" algn="ctr">
+                      <a:solidFill>
+                        <a:srgbClr val="DADCE0"/>
+                      </a:solidFill>
+                      <a:prstDash val="solid"/>
+                      <a:round/>
+                      <a:headEnd type="none" w="med" len="med"/>
+                      <a:tailEnd type="none" w="med" len="med"/>
+                    </a:lnR>
+                    <a:lnT w="9525" cap="flat" cmpd="sng" algn="ctr">
+                      <a:solidFill>
+                        <a:srgbClr val="DADCE0"/>
+                      </a:solidFill>
+                      <a:prstDash val="solid"/>
+                      <a:round/>
+                      <a:headEnd type="none" w="med" len="med"/>
+                      <a:tailEnd type="none" w="med" len="med"/>
+                    </a:lnT>
+                    <a:lnB w="9525" cap="flat" cmpd="sng" algn="ctr">
+                      <a:solidFill>
+                        <a:srgbClr val="DADCE0"/>
+                      </a:solidFill>
+                      <a:prstDash val="solid"/>
+                      <a:round/>
+                      <a:headEnd type="none" w="med" len="med"/>
+                      <a:tailEnd type="none" w="med" len="med"/>
+                    </a:lnB>
+                    <a:solidFill>
+                      <a:srgbClr val="FFFFFF"/>
+                    </a:solidFill>
+                  </a:tcPr>
+                </a:tc>
+                <a:tc>
+                  <a:txBody>
+                    <a:bodyPr/>
+                    <a:lstStyle/>
+                    <a:p>
+                      <a:pPr indent="0" marL="0">
+                        <a:buNone/>
+                      </a:pPr>
+                      <a:r>
+                        <a:rPr lang="en-US" sz="760" dirty="0">
+                          <a:solidFill>
+                            <a:srgbClr val="5F6368"/>
+                          </a:solidFill>
+                          <a:latin typeface="Roboto" pitchFamily="34" charset="0"/>
+                          <a:ea typeface="Roboto" pitchFamily="34" charset="-122"/>
+                          <a:cs typeface="Roboto" pitchFamily="34" charset="-120"/>
+                        </a:rPr>
+                        <a:t>Memorystore for Valkey RPM buckets (120/600 RPM, HTTP 429) + 4k/8k thinking clamps</a:t>
+                      </a:r>
+                      <a:endParaRPr lang="en-US" sz="760" dirty="0">
+                        <a:latin typeface="Roboto" charset="0"/>
+                        <a:ea typeface="Roboto" charset="0"/>
+                        <a:cs typeface="Roboto" charset="0"/>
+                      </a:endParaRPr>
+                    </a:p>
+                  </a:txBody>
+                  <a:tcPr marL="91440" marR="91440" marT="45720" marB="45720" anchor="ctr">
+                    <a:lnL w="9525" cap="flat" cmpd="sng" algn="ctr">
+                      <a:solidFill>
+                        <a:srgbClr val="DADCE0"/>
+                      </a:solidFill>
+                      <a:prstDash val="solid"/>
+                      <a:round/>
+                      <a:headEnd type="none" w="med" len="med"/>
+                      <a:tailEnd type="none" w="med" len="med"/>
+                    </a:lnL>
+                    <a:lnR w="9525" cap="flat" cmpd="sng" algn="ctr">
+                      <a:solidFill>
+                        <a:srgbClr val="DADCE0"/>
+                      </a:solidFill>
+                      <a:prstDash val="solid"/>
+                      <a:round/>
+                      <a:headEnd type="none" w="med" len="med"/>
+                      <a:tailEnd type="none" w="med" len="med"/>
+                    </a:lnR>
+                    <a:lnT w="9525" cap="flat" cmpd="sng" algn="ctr">
+                      <a:solidFill>
+                        <a:srgbClr val="DADCE0"/>
+                      </a:solidFill>
+                      <a:prstDash val="solid"/>
+                      <a:round/>
+                      <a:headEnd type="none" w="med" len="med"/>
+                      <a:tailEnd type="none" w="med" len="med"/>
+                    </a:lnT>
+                    <a:lnB w="9525" cap="flat" cmpd="sng" algn="ctr">
+                      <a:solidFill>
+                        <a:srgbClr val="DADCE0"/>
+                      </a:solidFill>
+                      <a:prstDash val="solid"/>
+                      <a:round/>
+                      <a:headEnd type="none" w="med" len="med"/>
+                      <a:tailEnd type="none" w="med" len="med"/>
+                    </a:lnB>
+                    <a:solidFill>
+                      <a:srgbClr val="FFFFFF"/>
+                    </a:solidFill>
+                  </a:tcPr>
+                </a:tc>
+                <a:tc>
+                  <a:txBody>
+                    <a:bodyPr/>
+                    <a:lstStyle/>
+                    <a:p>
+                      <a:pPr indent="0" marL="0">
+                        <a:buNone/>
+                      </a:pPr>
+                      <a:r>
+                        <a:rPr lang="en-US" sz="760" dirty="0">
+                          <a:solidFill>
+                            <a:srgbClr val="5F6368"/>
+                          </a:solidFill>
+                          <a:latin typeface="Roboto" pitchFamily="34" charset="0"/>
+                          <a:ea typeface="Roboto" pitchFamily="34" charset="-122"/>
+                          <a:cs typeface="Roboto" pitchFamily="34" charset="-120"/>
+                        </a:rPr>
+                        <a:t>Dedicated GCP project quota &amp; dedicated Provisioned Throughput / GKE GPUs</a:t>
+                      </a:r>
+                      <a:endParaRPr lang="en-US" sz="760" dirty="0">
+                        <a:latin typeface="Roboto" charset="0"/>
+                        <a:ea typeface="Roboto" charset="0"/>
+                        <a:cs typeface="Roboto" charset="0"/>
+                      </a:endParaRPr>
+                    </a:p>
+                  </a:txBody>
+                  <a:tcPr marL="91440" marR="91440" marT="45720" marB="45720" anchor="ctr">
+                    <a:lnL w="9525" cap="flat" cmpd="sng" algn="ctr">
+                      <a:solidFill>
+                        <a:srgbClr val="DADCE0"/>
+                      </a:solidFill>
+                      <a:prstDash val="solid"/>
+                      <a:round/>
+                      <a:headEnd type="none" w="med" len="med"/>
+                      <a:tailEnd type="none" w="med" len="med"/>
+                    </a:lnL>
+                    <a:lnR w="9525" cap="flat" cmpd="sng" algn="ctr">
+                      <a:solidFill>
+                        <a:srgbClr val="DADCE0"/>
+                      </a:solidFill>
+                      <a:prstDash val="solid"/>
+                      <a:round/>
+                      <a:headEnd type="none" w="med" len="med"/>
+                      <a:tailEnd type="none" w="med" len="med"/>
+                    </a:lnR>
+                    <a:lnT w="9525" cap="flat" cmpd="sng" algn="ctr">
+                      <a:solidFill>
+                        <a:srgbClr val="DADCE0"/>
+                      </a:solidFill>
+                      <a:prstDash val="solid"/>
+                      <a:round/>
+                      <a:headEnd type="none" w="med" len="med"/>
+                      <a:tailEnd type="none" w="med" len="med"/>
+                    </a:lnT>
+                    <a:lnB w="9525" cap="flat" cmpd="sng" algn="ctr">
+                      <a:solidFill>
+                        <a:srgbClr val="DADCE0"/>
+                      </a:solidFill>
+                      <a:prstDash val="solid"/>
+                      <a:round/>
+                      <a:headEnd type="none" w="med" len="med"/>
+                      <a:tailEnd type="none" w="med" len="med"/>
+                    </a:lnB>
+                    <a:solidFill>
+                      <a:srgbClr val="FFFFFF"/>
+                    </a:solidFill>
+                  </a:tcPr>
+                </a:tc>
+              </a:tr>
+              <a:tr h="0">
+                <a:tc>
+                  <a:txBody>
+                    <a:bodyPr/>
+                    <a:lstStyle/>
+                    <a:p>
+                      <a:pPr indent="0" marL="0">
+                        <a:buNone/>
+                      </a:pPr>
+                      <a:r>
+                        <a:rPr lang="en-US" sz="780" b="1" dirty="0">
+                          <a:solidFill>
+                            <a:srgbClr val="3C4043"/>
+                          </a:solidFill>
+                          <a:latin typeface="Google Sans" pitchFamily="34" charset="0"/>
+                          <a:ea typeface="Google Sans" pitchFamily="34" charset="-122"/>
+                          <a:cs typeface="Google Sans" pitchFamily="34" charset="-120"/>
+                        </a:rPr>
+                        <a:t>Prompt caching &amp; FinOps COGS</a:t>
+                      </a:r>
+                      <a:endParaRPr lang="en-US" sz="780" dirty="0">
+                        <a:latin typeface="Google Sans" charset="0"/>
+                        <a:ea typeface="Google Sans" charset="0"/>
+                        <a:cs typeface="Google Sans" charset="0"/>
+                      </a:endParaRPr>
+                    </a:p>
+                  </a:txBody>
+                  <a:tcPr marL="91440" marR="91440" marT="45720" marB="45720" anchor="ctr">
+                    <a:lnL w="9525" cap="flat" cmpd="sng" algn="ctr">
+                      <a:solidFill>
+                        <a:srgbClr val="DADCE0"/>
+                      </a:solidFill>
+                      <a:prstDash val="solid"/>
+                      <a:round/>
+                      <a:headEnd type="none" w="med" len="med"/>
+                      <a:tailEnd type="none" w="med" len="med"/>
+                    </a:lnL>
+                    <a:lnR w="9525" cap="flat" cmpd="sng" algn="ctr">
+                      <a:solidFill>
+                        <a:srgbClr val="DADCE0"/>
+                      </a:solidFill>
+                      <a:prstDash val="solid"/>
+                      <a:round/>
+                      <a:headEnd type="none" w="med" len="med"/>
+                      <a:tailEnd type="none" w="med" len="med"/>
+                    </a:lnR>
+                    <a:lnT w="9525" cap="flat" cmpd="sng" algn="ctr">
+                      <a:solidFill>
+                        <a:srgbClr val="DADCE0"/>
+                      </a:solidFill>
+                      <a:prstDash val="solid"/>
+                      <a:round/>
+                      <a:headEnd type="none" w="med" len="med"/>
+                      <a:tailEnd type="none" w="med" len="med"/>
+                    </a:lnT>
+                    <a:lnB w="9525" cap="flat" cmpd="sng" algn="ctr">
+                      <a:solidFill>
+                        <a:srgbClr val="DADCE0"/>
+                      </a:solidFill>
+                      <a:prstDash val="solid"/>
+                      <a:round/>
+                      <a:headEnd type="none" w="med" len="med"/>
+                      <a:tailEnd type="none" w="med" len="med"/>
+                    </a:lnB>
+                    <a:solidFill>
+                      <a:srgbClr val="F8F9FA"/>
+                    </a:solidFill>
+                  </a:tcPr>
+                </a:tc>
+                <a:tc>
+                  <a:txBody>
+                    <a:bodyPr/>
+                    <a:lstStyle/>
+                    <a:p>
+                      <a:pPr indent="0" marL="0">
+                        <a:buNone/>
+                      </a:pPr>
+                      <a:r>
+                        <a:rPr lang="en-US" sz="760" dirty="0">
+                          <a:solidFill>
+                            <a:srgbClr val="5F6368"/>
+                          </a:solidFill>
+                          <a:latin typeface="Roboto" pitchFamily="34" charset="0"/>
+                          <a:ea typeface="Roboto" pitchFamily="34" charset="-122"/>
+                          <a:cs typeface="Roboto" pitchFamily="34" charset="-120"/>
+                        </a:rPr>
+                        <a:t>34k prompt billed in full every turn ($0.0425/turn) or unsafe cross-tenant cache bleed</a:t>
+                      </a:r>
+                      <a:endParaRPr lang="en-US" sz="760" dirty="0">
+                        <a:latin typeface="Roboto" charset="0"/>
+                        <a:ea typeface="Roboto" charset="0"/>
+                        <a:cs typeface="Roboto" charset="0"/>
+                      </a:endParaRPr>
+                    </a:p>
+                  </a:txBody>
+                  <a:tcPr marL="91440" marR="91440" marT="45720" marB="45720" anchor="ctr">
+                    <a:lnL w="9525" cap="flat" cmpd="sng" algn="ctr">
+                      <a:solidFill>
+                        <a:srgbClr val="DADCE0"/>
+                      </a:solidFill>
+                      <a:prstDash val="solid"/>
+                      <a:round/>
+                      <a:headEnd type="none" w="med" len="med"/>
+                      <a:tailEnd type="none" w="med" len="med"/>
+                    </a:lnL>
+                    <a:lnR w="9525" cap="flat" cmpd="sng" algn="ctr">
+                      <a:solidFill>
+                        <a:srgbClr val="DADCE0"/>
+                      </a:solidFill>
+                      <a:prstDash val="solid"/>
+                      <a:round/>
+                      <a:headEnd type="none" w="med" len="med"/>
+                      <a:tailEnd type="none" w="med" len="med"/>
+                    </a:lnR>
+                    <a:lnT w="9525" cap="flat" cmpd="sng" algn="ctr">
+                      <a:solidFill>
+                        <a:srgbClr val="DADCE0"/>
+                      </a:solidFill>
+                      <a:prstDash val="solid"/>
+                      <a:round/>
+                      <a:headEnd type="none" w="med" len="med"/>
+                      <a:tailEnd type="none" w="med" len="med"/>
+                    </a:lnT>
+                    <a:lnB w="9525" cap="flat" cmpd="sng" algn="ctr">
+                      <a:solidFill>
+                        <a:srgbClr val="DADCE0"/>
+                      </a:solidFill>
+                      <a:prstDash val="solid"/>
+                      <a:round/>
+                      <a:headEnd type="none" w="med" len="med"/>
+                      <a:tailEnd type="none" w="med" len="med"/>
+                    </a:lnB>
+                    <a:solidFill>
+                      <a:srgbClr val="F8F9FA"/>
+                    </a:solidFill>
+                  </a:tcPr>
+                </a:tc>
+                <a:tc>
+                  <a:txBody>
+                    <a:bodyPr/>
+                    <a:lstStyle/>
+                    <a:p>
+                      <a:pPr indent="0" marL="0">
+                        <a:buNone/>
+                      </a:pPr>
+                      <a:r>
+                        <a:rPr lang="en-US" sz="760" dirty="0">
+                          <a:solidFill>
+                            <a:srgbClr val="5F6368"/>
+                          </a:solidFill>
+                          <a:latin typeface="Roboto" pitchFamily="34" charset="0"/>
+                          <a:ea typeface="Roboto" pitchFamily="34" charset="-122"/>
+                          <a:cs typeface="Roboto" pitchFamily="34" charset="-120"/>
+                        </a:rPr>
+                        <a:t>32k immutable prefix in Gemini 2.5 Pro ContextCacheConfig (90% discount -&gt; 84.7% savings)</a:t>
+                      </a:r>
+                      <a:endParaRPr lang="en-US" sz="760" dirty="0">
+                        <a:latin typeface="Roboto" charset="0"/>
+                        <a:ea typeface="Roboto" charset="0"/>
+                        <a:cs typeface="Roboto" charset="0"/>
+                      </a:endParaRPr>
+                    </a:p>
+                  </a:txBody>
+                  <a:tcPr marL="91440" marR="91440" marT="45720" marB="45720" anchor="ctr">
+                    <a:lnL w="9525" cap="flat" cmpd="sng" algn="ctr">
+                      <a:solidFill>
+                        <a:srgbClr val="DADCE0"/>
+                      </a:solidFill>
+                      <a:prstDash val="solid"/>
+                      <a:round/>
+                      <a:headEnd type="none" w="med" len="med"/>
+                      <a:tailEnd type="none" w="med" len="med"/>
+                    </a:lnL>
+                    <a:lnR w="9525" cap="flat" cmpd="sng" algn="ctr">
+                      <a:solidFill>
+                        <a:srgbClr val="DADCE0"/>
+                      </a:solidFill>
+                      <a:prstDash val="solid"/>
+                      <a:round/>
+                      <a:headEnd type="none" w="med" len="med"/>
+                      <a:tailEnd type="none" w="med" len="med"/>
+                    </a:lnR>
+                    <a:lnT w="9525" cap="flat" cmpd="sng" algn="ctr">
+                      <a:solidFill>
+                        <a:srgbClr val="DADCE0"/>
+                      </a:solidFill>
+                      <a:prstDash val="solid"/>
+                      <a:round/>
+                      <a:headEnd type="none" w="med" len="med"/>
+                      <a:tailEnd type="none" w="med" len="med"/>
+                    </a:lnT>
+                    <a:lnB w="9525" cap="flat" cmpd="sng" algn="ctr">
+                      <a:solidFill>
+                        <a:srgbClr val="DADCE0"/>
+                      </a:solidFill>
+                      <a:prstDash val="solid"/>
+                      <a:round/>
+                      <a:headEnd type="none" w="med" len="med"/>
+                      <a:tailEnd type="none" w="med" len="med"/>
+                    </a:lnB>
+                    <a:solidFill>
+                      <a:srgbClr val="F8F9FA"/>
+                    </a:solidFill>
+                  </a:tcPr>
+                </a:tc>
+                <a:tc>
+                  <a:txBody>
+                    <a:bodyPr/>
+                    <a:lstStyle/>
+                    <a:p>
+                      <a:pPr indent="0" marL="0">
+                        <a:buNone/>
+                      </a:pPr>
+                      <a:r>
+                        <a:rPr lang="en-US" sz="760" dirty="0">
+                          <a:solidFill>
+                            <a:srgbClr val="5F6368"/>
+                          </a:solidFill>
+                          <a:latin typeface="Roboto" pitchFamily="34" charset="0"/>
+                          <a:ea typeface="Roboto" pitchFamily="34" charset="-122"/>
+                          <a:cs typeface="Roboto" pitchFamily="34" charset="-120"/>
+                        </a:rPr>
+                        <a:t>Per-silo prefix cache or dedicated air-gapped GKE Gemma 3 (27B) node pool</a:t>
+                      </a:r>
+                      <a:endParaRPr lang="en-US" sz="760" dirty="0">
+                        <a:latin typeface="Roboto" charset="0"/>
+                        <a:ea typeface="Roboto" charset="0"/>
+                        <a:cs typeface="Roboto" charset="0"/>
+                      </a:endParaRPr>
+                    </a:p>
+                  </a:txBody>
+                  <a:tcPr marL="91440" marR="91440" marT="45720" marB="45720" anchor="ctr">
+                    <a:lnL w="9525" cap="flat" cmpd="sng" algn="ctr">
+                      <a:solidFill>
+                        <a:srgbClr val="DADCE0"/>
+                      </a:solidFill>
+                      <a:prstDash val="solid"/>
+                      <a:round/>
+                      <a:headEnd type="none" w="med" len="med"/>
+                      <a:tailEnd type="none" w="med" len="med"/>
+                    </a:lnL>
+                    <a:lnR w="9525" cap="flat" cmpd="sng" algn="ctr">
+                      <a:solidFill>
+                        <a:srgbClr val="DADCE0"/>
+                      </a:solidFill>
+                      <a:prstDash val="solid"/>
+                      <a:round/>
+                      <a:headEnd type="none" w="med" len="med"/>
+                      <a:tailEnd type="none" w="med" len="med"/>
+                    </a:lnR>
+                    <a:lnT w="9525" cap="flat" cmpd="sng" algn="ctr">
+                      <a:solidFill>
+                        <a:srgbClr val="DADCE0"/>
+                      </a:solidFill>
+                      <a:prstDash val="solid"/>
+                      <a:round/>
+                      <a:headEnd type="none" w="med" len="med"/>
+                      <a:tailEnd type="none" w="med" len="med"/>
+                    </a:lnT>
+                    <a:lnB w="9525" cap="flat" cmpd="sng" algn="ctr">
+                      <a:solidFill>
+                        <a:srgbClr val="DADCE0"/>
+                      </a:solidFill>
+                      <a:prstDash val="solid"/>
+                      <a:round/>
+                      <a:headEnd type="none" w="med" len="med"/>
+                      <a:tailEnd type="none" w="med" len="med"/>
+                    </a:lnB>
+                    <a:solidFill>
+                      <a:srgbClr val="F8F9FA"/>
+                    </a:solidFill>
+                  </a:tcPr>
+                </a:tc>
+              </a:tr>
+              <a:tr h="0">
+                <a:tc>
+                  <a:txBody>
+                    <a:bodyPr/>
+                    <a:lstStyle/>
+                    <a:p>
+                      <a:pPr indent="0" marL="0">
+                        <a:buNone/>
+                      </a:pPr>
+                      <a:r>
+                        <a:rPr lang="en-US" sz="780" b="1" dirty="0">
+                          <a:solidFill>
+                            <a:srgbClr val="3C4043"/>
+                          </a:solidFill>
+                          <a:latin typeface="Google Sans" pitchFamily="34" charset="0"/>
+                          <a:ea typeface="Google Sans" pitchFamily="34" charset="-122"/>
+                          <a:cs typeface="Google Sans" pitchFamily="34" charset="-120"/>
+                        </a:rPr>
+                        <a:t>Relational data &amp; PII guardrails</a:t>
+                      </a:r>
+                      <a:endParaRPr lang="en-US" sz="780" dirty="0">
+                        <a:latin typeface="Google Sans" charset="0"/>
+                        <a:ea typeface="Google Sans" charset="0"/>
+                        <a:cs typeface="Google Sans" charset="0"/>
+                      </a:endParaRPr>
+                    </a:p>
+                  </a:txBody>
+                  <a:tcPr marL="91440" marR="91440" marT="45720" marB="45720" anchor="ctr">
+                    <a:lnL w="9525" cap="flat" cmpd="sng" algn="ctr">
+                      <a:solidFill>
+                        <a:srgbClr val="DADCE0"/>
+                      </a:solidFill>
+                      <a:prstDash val="solid"/>
+                      <a:round/>
+                      <a:headEnd type="none" w="med" len="med"/>
+                      <a:tailEnd type="none" w="med" len="med"/>
+                    </a:lnL>
+                    <a:lnR w="9525" cap="flat" cmpd="sng" algn="ctr">
+                      <a:solidFill>
+                        <a:srgbClr val="DADCE0"/>
+                      </a:solidFill>
+                      <a:prstDash val="solid"/>
+                      <a:round/>
+                      <a:headEnd type="none" w="med" len="med"/>
+                      <a:tailEnd type="none" w="med" len="med"/>
+                    </a:lnR>
+                    <a:lnT w="9525" cap="flat" cmpd="sng" algn="ctr">
+                      <a:solidFill>
+                        <a:srgbClr val="DADCE0"/>
+                      </a:solidFill>
+                      <a:prstDash val="solid"/>
+                      <a:round/>
+                      <a:headEnd type="none" w="med" len="med"/>
+                      <a:tailEnd type="none" w="med" len="med"/>
+                    </a:lnT>
+                    <a:lnB w="9525" cap="flat" cmpd="sng" algn="ctr">
+                      <a:solidFill>
+                        <a:srgbClr val="DADCE0"/>
+                      </a:solidFill>
+                      <a:prstDash val="solid"/>
+                      <a:round/>
+                      <a:headEnd type="none" w="med" len="med"/>
+                      <a:tailEnd type="none" w="med" len="med"/>
+                    </a:lnB>
+                    <a:solidFill>
+                      <a:srgbClr val="FFFFFF"/>
+                    </a:solidFill>
+                  </a:tcPr>
+                </a:tc>
+                <a:tc>
+                  <a:txBody>
+                    <a:bodyPr/>
+                    <a:lstStyle/>
+                    <a:p>
+                      <a:pPr indent="0" marL="0">
+                        <a:buNone/>
+                      </a:pPr>
+                      <a:r>
+                        <a:rPr lang="en-US" sz="760" dirty="0">
+                          <a:solidFill>
+                            <a:srgbClr val="5F6368"/>
+                          </a:solidFill>
+                          <a:latin typeface="Roboto" pitchFamily="34" charset="0"/>
+                          <a:ea typeface="Roboto" pitchFamily="34" charset="-122"/>
+                          <a:cs typeface="Roboto" pitchFamily="34" charset="-120"/>
+                        </a:rPr>
+                        <a:t>Application-layer WHERE tenant_id = ? query (vulnerable to SQLi &amp; prompt injection)</a:t>
+                      </a:r>
+                      <a:endParaRPr lang="en-US" sz="760" dirty="0">
+                        <a:latin typeface="Roboto" charset="0"/>
+                        <a:ea typeface="Roboto" charset="0"/>
+                        <a:cs typeface="Roboto" charset="0"/>
+                      </a:endParaRPr>
+                    </a:p>
+                  </a:txBody>
+                  <a:tcPr marL="91440" marR="91440" marT="45720" marB="45720" anchor="ctr">
+                    <a:lnL w="9525" cap="flat" cmpd="sng" algn="ctr">
+                      <a:solidFill>
+                        <a:srgbClr val="DADCE0"/>
+                      </a:solidFill>
+                      <a:prstDash val="solid"/>
+                      <a:round/>
+                      <a:headEnd type="none" w="med" len="med"/>
+                      <a:tailEnd type="none" w="med" len="med"/>
+                    </a:lnL>
+                    <a:lnR w="9525" cap="flat" cmpd="sng" algn="ctr">
+                      <a:solidFill>
+                        <a:srgbClr val="DADCE0"/>
+                      </a:solidFill>
+                      <a:prstDash val="solid"/>
+                      <a:round/>
+                      <a:headEnd type="none" w="med" len="med"/>
+                      <a:tailEnd type="none" w="med" len="med"/>
+                    </a:lnR>
+                    <a:lnT w="9525" cap="flat" cmpd="sng" algn="ctr">
+                      <a:solidFill>
+                        <a:srgbClr val="DADCE0"/>
+                      </a:solidFill>
+                      <a:prstDash val="solid"/>
+                      <a:round/>
+                      <a:headEnd type="none" w="med" len="med"/>
+                      <a:tailEnd type="none" w="med" len="med"/>
+                    </a:lnT>
+                    <a:lnB w="9525" cap="flat" cmpd="sng" algn="ctr">
+                      <a:solidFill>
+                        <a:srgbClr val="DADCE0"/>
+                      </a:solidFill>
+                      <a:prstDash val="solid"/>
+                      <a:round/>
+                      <a:headEnd type="none" w="med" len="med"/>
+                      <a:tailEnd type="none" w="med" len="med"/>
+                    </a:lnB>
+                    <a:solidFill>
+                      <a:srgbClr val="FFFFFF"/>
+                    </a:solidFill>
+                  </a:tcPr>
+                </a:tc>
+                <a:tc>
+                  <a:txBody>
+                    <a:bodyPr/>
+                    <a:lstStyle/>
+                    <a:p>
+                      <a:pPr indent="0" marL="0">
+                        <a:buNone/>
+                      </a:pPr>
+                      <a:r>
+                        <a:rPr lang="en-US" sz="760" dirty="0">
+                          <a:solidFill>
+                            <a:srgbClr val="5F6368"/>
+                          </a:solidFill>
+                          <a:latin typeface="Roboto" pitchFamily="34" charset="0"/>
+                          <a:ea typeface="Roboto" pitchFamily="34" charset="-122"/>
+                          <a:cs typeface="Roboto" pitchFamily="34" charset="-120"/>
+                        </a:rPr>
+                        <a:t>AlloyDB FORCE ROW LEVEL SECURITY (SET LOCAL) + Model Armor (400/422) &amp; Cloud DLP</a:t>
+                      </a:r>
+                      <a:endParaRPr lang="en-US" sz="760" dirty="0">
+                        <a:latin typeface="Roboto" charset="0"/>
+                        <a:ea typeface="Roboto" charset="0"/>
+                        <a:cs typeface="Roboto" charset="0"/>
+                      </a:endParaRPr>
+                    </a:p>
+                  </a:txBody>
+                  <a:tcPr marL="91440" marR="91440" marT="45720" marB="45720" anchor="ctr">
+                    <a:lnL w="9525" cap="flat" cmpd="sng" algn="ctr">
+                      <a:solidFill>
+                        <a:srgbClr val="DADCE0"/>
+                      </a:solidFill>
+                      <a:prstDash val="solid"/>
+                      <a:round/>
+                      <a:headEnd type="none" w="med" len="med"/>
+                      <a:tailEnd type="none" w="med" len="med"/>
+                    </a:lnL>
+                    <a:lnR w="9525" cap="flat" cmpd="sng" algn="ctr">
+                      <a:solidFill>
+                        <a:srgbClr val="DADCE0"/>
+                      </a:solidFill>
+                      <a:prstDash val="solid"/>
+                      <a:round/>
+                      <a:headEnd type="none" w="med" len="med"/>
+                      <a:tailEnd type="none" w="med" len="med"/>
+                    </a:lnR>
+                    <a:lnT w="9525" cap="flat" cmpd="sng" algn="ctr">
+                      <a:solidFill>
+                        <a:srgbClr val="DADCE0"/>
+                      </a:solidFill>
+                      <a:prstDash val="solid"/>
+                      <a:round/>
+                      <a:headEnd type="none" w="med" len="med"/>
+                      <a:tailEnd type="none" w="med" len="med"/>
+                    </a:lnT>
+                    <a:lnB w="9525" cap="flat" cmpd="sng" algn="ctr">
+                      <a:solidFill>
+                        <a:srgbClr val="DADCE0"/>
+                      </a:solidFill>
+                      <a:prstDash val="solid"/>
+                      <a:round/>
+                      <a:headEnd type="none" w="med" len="med"/>
+                      <a:tailEnd type="none" w="med" len="med"/>
+                    </a:lnB>
+                    <a:solidFill>
+                      <a:srgbClr val="FFFFFF"/>
+                    </a:solidFill>
+                  </a:tcPr>
+                </a:tc>
+                <a:tc>
+                  <a:txBody>
+                    <a:bodyPr/>
+                    <a:lstStyle/>
+                    <a:p>
+                      <a:pPr indent="0" marL="0">
+                        <a:buNone/>
+                      </a:pPr>
+                      <a:r>
+                        <a:rPr lang="en-US" sz="760" dirty="0">
+                          <a:solidFill>
+                            <a:srgbClr val="5F6368"/>
+                          </a:solidFill>
+                          <a:latin typeface="Roboto" pitchFamily="34" charset="0"/>
+                          <a:ea typeface="Roboto" pitchFamily="34" charset="-122"/>
+                          <a:cs typeface="Roboto" pitchFamily="34" charset="-120"/>
+                        </a:rPr>
+                        <a:t>Dedicated CMEK AlloyDB instance + &lt;60s HTTP 423 Locked customer key kill-switch</a:t>
+                      </a:r>
+                      <a:endParaRPr lang="en-US" sz="760" dirty="0">
+                        <a:latin typeface="Roboto" charset="0"/>
+                        <a:ea typeface="Roboto" charset="0"/>
+                        <a:cs typeface="Roboto" charset="0"/>
+                      </a:endParaRPr>
+                    </a:p>
+                  </a:txBody>
+                  <a:tcPr marL="91440" marR="91440" marT="45720" marB="45720" anchor="ctr">
+                    <a:lnL w="9525" cap="flat" cmpd="sng" algn="ctr">
+                      <a:solidFill>
+                        <a:srgbClr val="DADCE0"/>
+                      </a:solidFill>
+                      <a:prstDash val="solid"/>
+                      <a:round/>
+                      <a:headEnd type="none" w="med" len="med"/>
+                      <a:tailEnd type="none" w="med" len="med"/>
+                    </a:lnL>
+                    <a:lnR w="9525" cap="flat" cmpd="sng" algn="ctr">
+                      <a:solidFill>
+                        <a:srgbClr val="DADCE0"/>
+                      </a:solidFill>
+                      <a:prstDash val="solid"/>
+                      <a:round/>
+                      <a:headEnd type="none" w="med" len="med"/>
+                      <a:tailEnd type="none" w="med" len="med"/>
+                    </a:lnR>
+                    <a:lnT w="9525" cap="flat" cmpd="sng" algn="ctr">
+                      <a:solidFill>
+                        <a:srgbClr val="DADCE0"/>
+                      </a:solidFill>
+                      <a:prstDash val="solid"/>
+                      <a:round/>
+                      <a:headEnd type="none" w="med" len="med"/>
+                      <a:tailEnd type="none" w="med" len="med"/>
+                    </a:lnT>
+                    <a:lnB w="9525" cap="flat" cmpd="sng" algn="ctr">
+                      <a:solidFill>
+                        <a:srgbClr val="DADCE0"/>
+                      </a:solidFill>
+                      <a:prstDash val="solid"/>
+                      <a:round/>
+                      <a:headEnd type="none" w="med" len="med"/>
+                      <a:tailEnd type="none" w="med" len="med"/>
+                    </a:lnB>
+                    <a:solidFill>
+                      <a:srgbClr val="FFFFFF"/>
+                    </a:solidFill>
+                  </a:tcPr>
+                </a:tc>
+              </a:tr>
+              <a:tr h="0">
+                <a:tc>
+                  <a:txBody>
+                    <a:bodyPr/>
+                    <a:lstStyle/>
+                    <a:p>
+                      <a:pPr indent="0" marL="0">
+                        <a:buNone/>
+                      </a:pPr>
+                      <a:r>
+                        <a:rPr lang="en-US" sz="780" b="1" dirty="0">
+                          <a:solidFill>
+                            <a:srgbClr val="3C4043"/>
+                          </a:solidFill>
+                          <a:latin typeface="Google Sans" pitchFamily="34" charset="0"/>
+                          <a:ea typeface="Google Sans" pitchFamily="34" charset="-122"/>
+                          <a:cs typeface="Google Sans" pitchFamily="34" charset="-120"/>
+                        </a:rPr>
+                        <a:t>Unit economics &amp; target tier</a:t>
+                      </a:r>
+                      <a:endParaRPr lang="en-US" sz="780" dirty="0">
+                        <a:latin typeface="Google Sans" charset="0"/>
+                        <a:ea typeface="Google Sans" charset="0"/>
+                        <a:cs typeface="Google Sans" charset="0"/>
+                      </a:endParaRPr>
+                    </a:p>
+                  </a:txBody>
+                  <a:tcPr marL="91440" marR="91440" marT="45720" marB="45720" anchor="ctr">
+                    <a:lnL w="9525" cap="flat" cmpd="sng" algn="ctr">
+                      <a:solidFill>
+                        <a:srgbClr val="DADCE0"/>
+                      </a:solidFill>
+                      <a:prstDash val="solid"/>
+                      <a:round/>
+                      <a:headEnd type="none" w="med" len="med"/>
+                      <a:tailEnd type="none" w="med" len="med"/>
+                    </a:lnL>
+                    <a:lnR w="9525" cap="flat" cmpd="sng" algn="ctr">
+                      <a:solidFill>
+                        <a:srgbClr val="DADCE0"/>
+                      </a:solidFill>
+                      <a:prstDash val="solid"/>
+                      <a:round/>
+                      <a:headEnd type="none" w="med" len="med"/>
+                      <a:tailEnd type="none" w="med" len="med"/>
+                    </a:lnR>
+                    <a:lnT w="9525" cap="flat" cmpd="sng" algn="ctr">
+                      <a:solidFill>
+                        <a:srgbClr val="DADCE0"/>
+                      </a:solidFill>
+                      <a:prstDash val="solid"/>
+                      <a:round/>
+                      <a:headEnd type="none" w="med" len="med"/>
+                      <a:tailEnd type="none" w="med" len="med"/>
+                    </a:lnT>
+                    <a:lnB w="9525" cap="flat" cmpd="sng" algn="ctr">
+                      <a:solidFill>
+                        <a:srgbClr val="DADCE0"/>
+                      </a:solidFill>
+                      <a:prstDash val="solid"/>
+                      <a:round/>
+                      <a:headEnd type="none" w="med" len="med"/>
+                      <a:tailEnd type="none" w="med" len="med"/>
+                    </a:lnB>
+                    <a:solidFill>
+                      <a:srgbClr val="F8F9FA"/>
+                    </a:solidFill>
+                  </a:tcPr>
+                </a:tc>
+                <a:tc>
+                  <a:txBody>
+                    <a:bodyPr/>
+                    <a:lstStyle/>
+                    <a:p>
+                      <a:pPr indent="0" marL="0">
+                        <a:buNone/>
+                      </a:pPr>
+                      <a:r>
+                        <a:rPr lang="en-US" sz="760" dirty="0">
+                          <a:solidFill>
+                            <a:srgbClr val="5F6368"/>
+                          </a:solidFill>
+                          <a:latin typeface="Roboto" pitchFamily="34" charset="0"/>
+                          <a:ea typeface="Roboto" pitchFamily="34" charset="-122"/>
+                          <a:cs typeface="Roboto" pitchFamily="34" charset="-120"/>
+                        </a:rPr>
+                        <a:t>High breach risk • Fails enterprise CISO security &amp; compliance review</a:t>
+                      </a:r>
+                      <a:endParaRPr lang="en-US" sz="760" dirty="0">
+                        <a:latin typeface="Roboto" charset="0"/>
+                        <a:ea typeface="Roboto" charset="0"/>
+                        <a:cs typeface="Roboto" charset="0"/>
+                      </a:endParaRPr>
+                    </a:p>
+                  </a:txBody>
+                  <a:tcPr marL="91440" marR="91440" marT="45720" marB="45720" anchor="ctr">
+                    <a:lnL w="9525" cap="flat" cmpd="sng" algn="ctr">
+                      <a:solidFill>
+                        <a:srgbClr val="DADCE0"/>
+                      </a:solidFill>
+                      <a:prstDash val="solid"/>
+                      <a:round/>
+                      <a:headEnd type="none" w="med" len="med"/>
+                      <a:tailEnd type="none" w="med" len="med"/>
+                    </a:lnL>
+                    <a:lnR w="9525" cap="flat" cmpd="sng" algn="ctr">
+                      <a:solidFill>
+                        <a:srgbClr val="DADCE0"/>
+                      </a:solidFill>
+                      <a:prstDash val="solid"/>
+                      <a:round/>
+                      <a:headEnd type="none" w="med" len="med"/>
+                      <a:tailEnd type="none" w="med" len="med"/>
+                    </a:lnR>
+                    <a:lnT w="9525" cap="flat" cmpd="sng" algn="ctr">
+                      <a:solidFill>
+                        <a:srgbClr val="DADCE0"/>
+                      </a:solidFill>
+                      <a:prstDash val="solid"/>
+                      <a:round/>
+                      <a:headEnd type="none" w="med" len="med"/>
+                      <a:tailEnd type="none" w="med" len="med"/>
+                    </a:lnT>
+                    <a:lnB w="9525" cap="flat" cmpd="sng" algn="ctr">
+                      <a:solidFill>
+                        <a:srgbClr val="DADCE0"/>
+                      </a:solidFill>
+                      <a:prstDash val="solid"/>
+                      <a:round/>
+                      <a:headEnd type="none" w="med" len="med"/>
+                      <a:tailEnd type="none" w="med" len="med"/>
+                    </a:lnB>
+                    <a:solidFill>
+                      <a:srgbClr val="F8F9FA"/>
+                    </a:solidFill>
+                  </a:tcPr>
+                </a:tc>
+                <a:tc>
+                  <a:txBody>
+                    <a:bodyPr/>
+                    <a:lstStyle/>
+                    <a:p>
+                      <a:pPr indent="0" marL="0">
+                        <a:buNone/>
+                      </a:pPr>
+                      <a:r>
+                        <a:rPr lang="en-US" sz="760" dirty="0">
+                          <a:solidFill>
+                            <a:srgbClr val="5F6368"/>
+                          </a:solidFill>
+                          <a:latin typeface="Roboto" pitchFamily="34" charset="0"/>
+                          <a:ea typeface="Roboto" pitchFamily="34" charset="-122"/>
+                          <a:cs typeface="Roboto" pitchFamily="34" charset="-120"/>
+                        </a:rPr>
+                        <a:t>$42 / tenant / month • High-volume commercial B2B SaaS (10/10 breach tests PASS)</a:t>
+                      </a:r>
+                      <a:endParaRPr lang="en-US" sz="760" dirty="0">
+                        <a:latin typeface="Roboto" charset="0"/>
+                        <a:ea typeface="Roboto" charset="0"/>
+                        <a:cs typeface="Roboto" charset="0"/>
+                      </a:endParaRPr>
+                    </a:p>
+                  </a:txBody>
+                  <a:tcPr marL="91440" marR="91440" marT="45720" marB="45720" anchor="ctr">
+                    <a:lnL w="9525" cap="flat" cmpd="sng" algn="ctr">
+                      <a:solidFill>
+                        <a:srgbClr val="DADCE0"/>
+                      </a:solidFill>
+                      <a:prstDash val="solid"/>
+                      <a:round/>
+                      <a:headEnd type="none" w="med" len="med"/>
+                      <a:tailEnd type="none" w="med" len="med"/>
+                    </a:lnL>
+                    <a:lnR w="9525" cap="flat" cmpd="sng" algn="ctr">
+                      <a:solidFill>
+                        <a:srgbClr val="DADCE0"/>
+                      </a:solidFill>
+                      <a:prstDash val="solid"/>
+                      <a:round/>
+                      <a:headEnd type="none" w="med" len="med"/>
+                      <a:tailEnd type="none" w="med" len="med"/>
+                    </a:lnR>
+                    <a:lnT w="9525" cap="flat" cmpd="sng" algn="ctr">
+                      <a:solidFill>
+                        <a:srgbClr val="DADCE0"/>
+                      </a:solidFill>
+                      <a:prstDash val="solid"/>
+                      <a:round/>
+                      <a:headEnd type="none" w="med" len="med"/>
+                      <a:tailEnd type="none" w="med" len="med"/>
+                    </a:lnT>
+                    <a:lnB w="9525" cap="flat" cmpd="sng" algn="ctr">
+                      <a:solidFill>
+                        <a:srgbClr val="DADCE0"/>
+                      </a:solidFill>
+                      <a:prstDash val="solid"/>
+                      <a:round/>
+                      <a:headEnd type="none" w="med" len="med"/>
+                      <a:tailEnd type="none" w="med" len="med"/>
+                    </a:lnB>
+                    <a:solidFill>
+                      <a:srgbClr val="F8F9FA"/>
+                    </a:solidFill>
+                  </a:tcPr>
+                </a:tc>
+                <a:tc>
+                  <a:txBody>
+                    <a:bodyPr/>
+                    <a:lstStyle/>
+                    <a:p>
+                      <a:pPr indent="0" marL="0">
+                        <a:buNone/>
+                      </a:pPr>
+                      <a:r>
+                        <a:rPr lang="en-US" sz="760" b="1" dirty="0">
+                          <a:solidFill>
+                            <a:srgbClr val="0D652D"/>
+                          </a:solidFill>
+                          <a:latin typeface="Roboto" pitchFamily="34" charset="0"/>
+                          <a:ea typeface="Roboto" pitchFamily="34" charset="-122"/>
+                          <a:cs typeface="Roboto" pitchFamily="34" charset="-120"/>
+                        </a:rPr>
+                        <a:t>$1,850 / tenant / month • Regulated Banking, Healthcare &amp; Public Sector (6/6 PASS)</a:t>
+                      </a:r>
+                      <a:endParaRPr lang="en-US" sz="760" dirty="0">
+                        <a:latin typeface="Roboto" charset="0"/>
+                        <a:ea typeface="Roboto" charset="0"/>
+                        <a:cs typeface="Roboto" charset="0"/>
+                      </a:endParaRPr>
+                    </a:p>
+                  </a:txBody>
+                  <a:tcPr marL="91440" marR="91440" marT="45720" marB="45720" anchor="ctr">
+                    <a:lnL w="9525" cap="flat" cmpd="sng" algn="ctr">
+                      <a:solidFill>
+                        <a:srgbClr val="DADCE0"/>
+                      </a:solidFill>
+                      <a:prstDash val="solid"/>
+                      <a:round/>
+                      <a:headEnd type="none" w="med" len="med"/>
+                      <a:tailEnd type="none" w="med" len="med"/>
+                    </a:lnL>
+                    <a:lnR w="9525" cap="flat" cmpd="sng" algn="ctr">
+                      <a:solidFill>
+                        <a:srgbClr val="DADCE0"/>
+                      </a:solidFill>
+                      <a:prstDash val="solid"/>
+                      <a:round/>
+                      <a:headEnd type="none" w="med" len="med"/>
+                      <a:tailEnd type="none" w="med" len="med"/>
+                    </a:lnR>
+                    <a:lnT w="9525" cap="flat" cmpd="sng" algn="ctr">
+                      <a:solidFill>
+                        <a:srgbClr val="DADCE0"/>
+                      </a:solidFill>
+                      <a:prstDash val="solid"/>
+                      <a:round/>
+                      <a:headEnd type="none" w="med" len="med"/>
+                      <a:tailEnd type="none" w="med" len="med"/>
+                    </a:lnT>
+                    <a:lnB w="9525" cap="flat" cmpd="sng" algn="ctr">
+                      <a:solidFill>
+                        <a:srgbClr val="DADCE0"/>
+                      </a:solidFill>
+                      <a:prstDash val="solid"/>
+                      <a:round/>
+                      <a:headEnd type="none" w="med" len="med"/>
+                      <a:tailEnd type="none" w="med" len="med"/>
+                    </a:lnB>
+                    <a:solidFill>
+                      <a:srgbClr val="F8F9FA"/>
+                    </a:solidFill>
+                  </a:tcPr>
+                </a:tc>
+              </a:tr>
+            </a:tbl>
+          </a:graphicData>
+        </a:graphic>
+      </p:graphicFrame>
+      <p:sp>
+        <p:nvSpPr>
+          <p:cNvPr id="20" name="Shape 17"/>
+          <p:cNvSpPr/>
+          <p:nvPr/>
+        </p:nvSpPr>
+        <p:spPr>
+          <a:xfrm>
+            <a:off x="411480" y="4663440"/>
+            <a:ext cx="2718511" cy="1408176"/>
           </a:xfrm>
           <a:prstGeom prst="roundRect">
             <a:avLst>
-              <a:gd name="adj" fmla="val 3239"/>
+              <a:gd name="adj" fmla="val 5195"/>
             </a:avLst>
           </a:prstGeom>
           <a:solidFill>
@@ -19485,14 +21432,14 @@
       </p:sp>
       <p:sp>
         <p:nvSpPr>
-          <p:cNvPr id="20" name="Shape 18"/>
-          <p:cNvSpPr/>
-          <p:nvPr/>
-        </p:nvSpPr>
-        <p:spPr>
-          <a:xfrm>
-            <a:off x="411480" y="1353312"/>
-            <a:ext cx="5583326" cy="59436"/>
+          <p:cNvPr id="21" name="Shape 18"/>
+          <p:cNvSpPr/>
+          <p:nvPr/>
+        </p:nvSpPr>
+        <p:spPr>
+          <a:xfrm>
+            <a:off x="411480" y="4663440"/>
+            <a:ext cx="2718511" cy="50292"/>
           </a:xfrm>
           <a:prstGeom prst="rect">
             <a:avLst/>
@@ -19505,150 +21452,73 @@
       </p:sp>
       <p:sp>
         <p:nvSpPr>
-          <p:cNvPr id="21" name="Shape 19"/>
-          <p:cNvSpPr/>
-          <p:nvPr/>
-        </p:nvSpPr>
-        <p:spPr>
-          <a:xfrm>
-            <a:off x="557784" y="1481328"/>
-            <a:ext cx="365760" cy="256032"/>
-          </a:xfrm>
-          <a:prstGeom prst="roundRect">
-            <a:avLst>
-              <a:gd name="adj" fmla="val 21429"/>
-            </a:avLst>
-          </a:prstGeom>
-          <a:solidFill>
-            <a:srgbClr val="E8F0FE"/>
-          </a:solidFill>
-          <a:ln/>
-        </p:spPr>
-      </p:sp>
-      <p:sp>
-        <p:nvSpPr>
-          <p:cNvPr id="22" name="Text 20"/>
-          <p:cNvSpPr/>
-          <p:nvPr/>
-        </p:nvSpPr>
-        <p:spPr>
-          <a:xfrm>
-            <a:off x="557784" y="1481328"/>
-            <a:ext cx="365760" cy="256032"/>
-          </a:xfrm>
-          <a:prstGeom prst="rect">
-            <a:avLst/>
-          </a:prstGeom>
-          <a:noFill/>
-          <a:ln/>
-        </p:spPr>
-        <p:txBody>
-          <a:bodyPr wrap="square" rtlCol="0" anchor="ctr"/>
-          <a:lstStyle/>
-          <a:p>
-            <a:pPr algn="ctr" indent="0" marL="0">
-              <a:buNone/>
-            </a:pPr>
-            <a:r>
-              <a:rPr lang="en-US" sz="920" b="1" dirty="0">
-                <a:solidFill>
-                  <a:srgbClr val="174EA6"/>
+          <p:cNvPr id="22" name="Text 19"/>
+          <p:cNvSpPr/>
+          <p:nvPr/>
+        </p:nvSpPr>
+        <p:spPr>
+          <a:xfrm>
+            <a:off x="521208" y="4736592"/>
+            <a:ext cx="2499055" cy="256032"/>
+          </a:xfrm>
+          <a:prstGeom prst="rect">
+            <a:avLst/>
+          </a:prstGeom>
+          <a:noFill/>
+          <a:ln/>
+        </p:spPr>
+        <p:txBody>
+          <a:bodyPr wrap="square" rtlCol="0" anchor="ctr">
+            <a:normAutofit/>
+          </a:bodyPr>
+          <a:lstStyle/>
+          <a:p>
+            <a:pPr indent="0" marL="0">
+              <a:buNone/>
+            </a:pPr>
+            <a:r>
+              <a:rPr lang="en-US" sz="760" b="1" dirty="0">
+                <a:solidFill>
+                  <a:srgbClr val="3C4043"/>
                 </a:solidFill>
                 <a:latin typeface="Google Sans" pitchFamily="34" charset="0"/>
                 <a:ea typeface="Google Sans" pitchFamily="34" charset="-122"/>
                 <a:cs typeface="Google Sans" pitchFamily="34" charset="-120"/>
               </a:rPr>
-              <a:t>01</a:t>
-            </a:r>
-            <a:endParaRPr lang="en-US" sz="920" dirty="0"/>
-          </a:p>
-        </p:txBody>
-      </p:sp>
-      <p:sp>
-        <p:nvSpPr>
-          <p:cNvPr id="23" name="Text 21"/>
-          <p:cNvSpPr/>
-          <p:nvPr/>
-        </p:nvSpPr>
-        <p:spPr>
-          <a:xfrm>
-            <a:off x="996696" y="1463040"/>
-            <a:ext cx="4851806" cy="329184"/>
-          </a:xfrm>
-          <a:prstGeom prst="rect">
-            <a:avLst/>
-          </a:prstGeom>
-          <a:noFill/>
-          <a:ln/>
-        </p:spPr>
-        <p:txBody>
-          <a:bodyPr wrap="square" rtlCol="0" anchor="ctr"/>
+              <a:t>1. Why Naive Shared SaaS Fails Audits</a:t>
+            </a:r>
+            <a:endParaRPr lang="en-US" sz="760" dirty="0"/>
+          </a:p>
+        </p:txBody>
+      </p:sp>
+      <p:sp>
+        <p:nvSpPr>
+          <p:cNvPr id="23" name="Text 20"/>
+          <p:cNvSpPr/>
+          <p:nvPr/>
+        </p:nvSpPr>
+        <p:spPr>
+          <a:xfrm>
+            <a:off x="521208" y="4992624"/>
+            <a:ext cx="2499055" cy="1024128"/>
+          </a:xfrm>
+          <a:prstGeom prst="rect">
+            <a:avLst/>
+          </a:prstGeom>
+          <a:noFill/>
+          <a:ln/>
+        </p:spPr>
+        <p:txBody>
+          <a:bodyPr wrap="square" rtlCol="0" anchor="t">
+            <a:normAutofit/>
+          </a:bodyPr>
           <a:lstStyle/>
           <a:p>
             <a:pPr indent="0" marL="0">
               <a:buNone/>
             </a:pPr>
             <a:r>
-              <a:rPr lang="en-US" sz="1140" b="1" dirty="0">
-                <a:solidFill>
-                  <a:srgbClr val="3C4043"/>
-                </a:solidFill>
-                <a:latin typeface="Google Sans" pitchFamily="34" charset="0"/>
-                <a:ea typeface="Google Sans" pitchFamily="34" charset="-122"/>
-                <a:cs typeface="Google Sans" pitchFamily="34" charset="-120"/>
-              </a:rPr>
-              <a:t>Agentic AI &amp; Shared Prefix Caching</a:t>
-            </a:r>
-            <a:endParaRPr lang="en-US" sz="1140" dirty="0"/>
-          </a:p>
-        </p:txBody>
-      </p:sp>
-      <p:sp>
-        <p:nvSpPr>
-          <p:cNvPr id="24" name="Shape 22"/>
-          <p:cNvSpPr/>
-          <p:nvPr/>
-        </p:nvSpPr>
-        <p:spPr>
-          <a:xfrm>
-            <a:off x="557784" y="1847088"/>
-            <a:ext cx="5290718" cy="9144"/>
-          </a:xfrm>
-          <a:prstGeom prst="rect">
-            <a:avLst/>
-          </a:prstGeom>
-          <a:solidFill>
-            <a:srgbClr val="DADCE0"/>
-          </a:solidFill>
-          <a:ln/>
-        </p:spPr>
-      </p:sp>
-      <p:sp>
-        <p:nvSpPr>
-          <p:cNvPr id="25" name="Text 23"/>
-          <p:cNvSpPr/>
-          <p:nvPr/>
-        </p:nvSpPr>
-        <p:spPr>
-          <a:xfrm>
-            <a:off x="557784" y="1901952"/>
-            <a:ext cx="5290718" cy="850392"/>
-          </a:xfrm>
-          <a:prstGeom prst="rect">
-            <a:avLst/>
-          </a:prstGeom>
-          <a:noFill/>
-          <a:ln/>
-        </p:spPr>
-        <p:txBody>
-          <a:bodyPr wrap="square" rtlCol="0" anchor="t"/>
-          <a:lstStyle/>
-          <a:p>
-            <a:pPr indent="0" marL="0">
-              <a:buNone/>
-            </a:pPr>
-            <a:r>
-              <a:rPr lang="en-US" sz="980" dirty="0">
+              <a:rPr lang="en-US" sz="740" dirty="0">
                 <a:solidFill>
                   <a:srgbClr val="5F6368"/>
                 </a:solidFill>
@@ -19656,188 +21526,26 @@
                 <a:ea typeface="Roboto" pitchFamily="34" charset="-122"/>
                 <a:cs typeface="Roboto" pitchFamily="34" charset="-120"/>
               </a:rPr>
-              <a:t>Vertex AI Agent Engine (ADK 2.0 runtime, Agent Registry &amp; L1–L5 Memory Bank) and Gemini 2.5 Pro with ContextCacheConfig caching a 32,000-token immutable system prefix at a 90% discount (84.7% net token savings).</a:t>
-            </a:r>
-            <a:endParaRPr lang="en-US" sz="980" dirty="0"/>
-          </a:p>
-        </p:txBody>
-      </p:sp>
-      <p:sp>
-        <p:nvSpPr>
-          <p:cNvPr id="26" name="Shape 24"/>
-          <p:cNvSpPr/>
-          <p:nvPr/>
-        </p:nvSpPr>
-        <p:spPr>
-          <a:xfrm>
-            <a:off x="557784" y="2788920"/>
-            <a:ext cx="5290718" cy="493776"/>
+              <a:t>Ambient IAM service accounts, client-trusted X-Tenant-Id headers, and unpartitioned vector/SQL stores fail every red-team isolation test.</a:t>
+            </a:r>
+            <a:endParaRPr lang="en-US" sz="740" dirty="0"/>
+          </a:p>
+        </p:txBody>
+      </p:sp>
+      <p:sp>
+        <p:nvSpPr>
+          <p:cNvPr id="24" name="Shape 21"/>
+          <p:cNvSpPr/>
+          <p:nvPr/>
+        </p:nvSpPr>
+        <p:spPr>
+          <a:xfrm>
+            <a:off x="3294583" y="4663440"/>
+            <a:ext cx="2718511" cy="1408176"/>
           </a:xfrm>
           <a:prstGeom prst="roundRect">
             <a:avLst>
-              <a:gd name="adj" fmla="val 11111"/>
-            </a:avLst>
-          </a:prstGeom>
-          <a:solidFill>
-            <a:srgbClr val="FFFFFF"/>
-          </a:solidFill>
-          <a:ln w="9525">
-            <a:solidFill>
-              <a:srgbClr val="DADCE0"/>
-            </a:solidFill>
-            <a:prstDash val="solid"/>
-          </a:ln>
-        </p:spPr>
-      </p:sp>
-      <p:sp>
-        <p:nvSpPr>
-          <p:cNvPr id="27" name="Shape 25"/>
-          <p:cNvSpPr/>
-          <p:nvPr/>
-        </p:nvSpPr>
-        <p:spPr>
-          <a:xfrm>
-            <a:off x="557784" y="2788920"/>
-            <a:ext cx="54864" cy="493776"/>
-          </a:xfrm>
-          <a:prstGeom prst="rect">
-            <a:avLst/>
-          </a:prstGeom>
-          <a:solidFill>
-            <a:srgbClr val="4285F4"/>
-          </a:solidFill>
-          <a:ln/>
-        </p:spPr>
-      </p:sp>
-      <p:sp>
-        <p:nvSpPr>
-          <p:cNvPr id="28" name="Text 26"/>
-          <p:cNvSpPr/>
-          <p:nvPr/>
-        </p:nvSpPr>
-        <p:spPr>
-          <a:xfrm>
-            <a:off x="649224" y="2816352"/>
-            <a:ext cx="5162702" cy="438912"/>
-          </a:xfrm>
-          <a:prstGeom prst="rect">
-            <a:avLst/>
-          </a:prstGeom>
-          <a:noFill/>
-          <a:ln/>
-        </p:spPr>
-        <p:txBody>
-          <a:bodyPr wrap="square" rtlCol="0" anchor="ctr"/>
-          <a:lstStyle/>
-          <a:p>
-            <a:pPr indent="0" marL="0">
-              <a:buNone/>
-            </a:pPr>
-            <a:r>
-              <a:rPr lang="en-US" sz="750" b="1" dirty="0">
-                <a:solidFill>
-                  <a:srgbClr val="3C4043"/>
-                </a:solidFill>
-                <a:latin typeface="Google Sans" pitchFamily="34" charset="0"/>
-                <a:ea typeface="Google Sans" pitchFamily="34" charset="-122"/>
-                <a:cs typeface="Google Sans" pitchFamily="34" charset="-120"/>
-              </a:rPr>
-              <a:t>Cloud Stack: Vertex AI Agent Engine (ADK 2.0) • Gemini 2.5 Pro ContextCacheConfig (32k Shared System Prefix)
-</a:t>
-            </a:r>
-            <a:pPr indent="0" marL="0">
-              <a:buNone/>
-            </a:pPr>
-            <a:r>
-              <a:rPr lang="en-US" sz="730" dirty="0">
-                <a:solidFill>
-                  <a:srgbClr val="5F6368"/>
-                </a:solidFill>
-                <a:latin typeface="Roboto" pitchFamily="34" charset="0"/>
-                <a:ea typeface="Roboto" pitchFamily="34" charset="-122"/>
-                <a:cs typeface="Roboto" pitchFamily="34" charset="-120"/>
-              </a:rPr>
-              <a:t>Target &amp; SLA: 90% Cached Input Token Discount • Cuts Billable Input Tokens from 34,000 to 5,200/Turn (84.7% Savings)</a:t>
-            </a:r>
-            <a:endParaRPr lang="en-US" sz="750" dirty="0"/>
-          </a:p>
-        </p:txBody>
-      </p:sp>
-      <p:sp>
-        <p:nvSpPr>
-          <p:cNvPr id="29" name="Shape 27"/>
-          <p:cNvSpPr/>
-          <p:nvPr/>
-        </p:nvSpPr>
-        <p:spPr>
-          <a:xfrm>
-            <a:off x="557784" y="3337560"/>
-            <a:ext cx="5290718" cy="219456"/>
-          </a:xfrm>
-          <a:prstGeom prst="roundRect">
-            <a:avLst>
-              <a:gd name="adj" fmla="val 20833"/>
-            </a:avLst>
-          </a:prstGeom>
-          <a:solidFill>
-            <a:srgbClr val="E8F0FE"/>
-          </a:solidFill>
-          <a:ln/>
-        </p:spPr>
-      </p:sp>
-      <p:sp>
-        <p:nvSpPr>
-          <p:cNvPr id="30" name="Text 28"/>
-          <p:cNvSpPr/>
-          <p:nvPr/>
-        </p:nvSpPr>
-        <p:spPr>
-          <a:xfrm>
-            <a:off x="612648" y="3337560"/>
-            <a:ext cx="5180990" cy="219456"/>
-          </a:xfrm>
-          <a:prstGeom prst="rect">
-            <a:avLst/>
-          </a:prstGeom>
-          <a:noFill/>
-          <a:ln/>
-        </p:spPr>
-        <p:txBody>
-          <a:bodyPr wrap="square" rtlCol="0" anchor="ctr"/>
-          <a:lstStyle/>
-          <a:p>
-            <a:pPr indent="0" marL="0">
-              <a:buNone/>
-            </a:pPr>
-            <a:r>
-              <a:rPr lang="en-US" sz="750" b="1" dirty="0">
-                <a:solidFill>
-                  <a:srgbClr val="174EA6"/>
-                </a:solidFill>
-                <a:latin typeface="Google Sans" pitchFamily="34" charset="0"/>
-                <a:ea typeface="Google Sans" pitchFamily="34" charset="-122"/>
-                <a:cs typeface="Google Sans" pitchFamily="34" charset="-120"/>
-              </a:rPr>
-              <a:t>1. Agentic AI &amp; Prefix Cache</a:t>
-            </a:r>
-            <a:endParaRPr lang="en-US" sz="750" dirty="0"/>
-          </a:p>
-        </p:txBody>
-      </p:sp>
-      <p:sp>
-        <p:nvSpPr>
-          <p:cNvPr id="31" name="Shape 29"/>
-          <p:cNvSpPr/>
-          <p:nvPr/>
-        </p:nvSpPr>
-        <p:spPr>
-          <a:xfrm>
-            <a:off x="6195974" y="1353312"/>
-            <a:ext cx="5583326" cy="2258568"/>
-          </a:xfrm>
-          <a:prstGeom prst="roundRect">
-            <a:avLst>
-              <a:gd name="adj" fmla="val 3239"/>
+              <a:gd name="adj" fmla="val 5195"/>
             </a:avLst>
           </a:prstGeom>
           <a:solidFill>
@@ -19853,14 +21561,14 @@
       </p:sp>
       <p:sp>
         <p:nvSpPr>
-          <p:cNvPr id="32" name="Shape 30"/>
-          <p:cNvSpPr/>
-          <p:nvPr/>
-        </p:nvSpPr>
-        <p:spPr>
-          <a:xfrm>
-            <a:off x="6195974" y="1353312"/>
-            <a:ext cx="5583326" cy="59436"/>
+          <p:cNvPr id="25" name="Shape 22"/>
+          <p:cNvSpPr/>
+          <p:nvPr/>
+        </p:nvSpPr>
+        <p:spPr>
+          <a:xfrm>
+            <a:off x="3294583" y="4663440"/>
+            <a:ext cx="2718511" cy="50292"/>
           </a:xfrm>
           <a:prstGeom prst="rect">
             <a:avLst/>
@@ -19873,150 +21581,73 @@
       </p:sp>
       <p:sp>
         <p:nvSpPr>
-          <p:cNvPr id="33" name="Shape 31"/>
-          <p:cNvSpPr/>
-          <p:nvPr/>
-        </p:nvSpPr>
-        <p:spPr>
-          <a:xfrm>
-            <a:off x="6342278" y="1481328"/>
-            <a:ext cx="365760" cy="256032"/>
-          </a:xfrm>
-          <a:prstGeom prst="roundRect">
-            <a:avLst>
-              <a:gd name="adj" fmla="val 21429"/>
-            </a:avLst>
-          </a:prstGeom>
-          <a:solidFill>
-            <a:srgbClr val="FCE8E6"/>
-          </a:solidFill>
-          <a:ln/>
-        </p:spPr>
-      </p:sp>
-      <p:sp>
-        <p:nvSpPr>
-          <p:cNvPr id="34" name="Text 32"/>
-          <p:cNvSpPr/>
-          <p:nvPr/>
-        </p:nvSpPr>
-        <p:spPr>
-          <a:xfrm>
-            <a:off x="6342278" y="1481328"/>
-            <a:ext cx="365760" cy="256032"/>
-          </a:xfrm>
-          <a:prstGeom prst="rect">
-            <a:avLst/>
-          </a:prstGeom>
-          <a:noFill/>
-          <a:ln/>
-        </p:spPr>
-        <p:txBody>
-          <a:bodyPr wrap="square" rtlCol="0" anchor="ctr"/>
-          <a:lstStyle/>
-          <a:p>
-            <a:pPr algn="ctr" indent="0" marL="0">
-              <a:buNone/>
-            </a:pPr>
-            <a:r>
-              <a:rPr lang="en-US" sz="920" b="1" dirty="0">
-                <a:solidFill>
-                  <a:srgbClr val="A50E0E"/>
+          <p:cNvPr id="26" name="Text 23"/>
+          <p:cNvSpPr/>
+          <p:nvPr/>
+        </p:nvSpPr>
+        <p:spPr>
+          <a:xfrm>
+            <a:off x="3404311" y="4736592"/>
+            <a:ext cx="2499055" cy="256032"/>
+          </a:xfrm>
+          <a:prstGeom prst="rect">
+            <a:avLst/>
+          </a:prstGeom>
+          <a:noFill/>
+          <a:ln/>
+        </p:spPr>
+        <p:txBody>
+          <a:bodyPr wrap="square" rtlCol="0" anchor="ctr">
+            <a:normAutofit/>
+          </a:bodyPr>
+          <a:lstStyle/>
+          <a:p>
+            <a:pPr indent="0" marL="0">
+              <a:buNone/>
+            </a:pPr>
+            <a:r>
+              <a:rPr lang="en-US" sz="760" b="1" dirty="0">
+                <a:solidFill>
+                  <a:srgbClr val="3C4043"/>
                 </a:solidFill>
                 <a:latin typeface="Google Sans" pitchFamily="34" charset="0"/>
                 <a:ea typeface="Google Sans" pitchFamily="34" charset="-122"/>
                 <a:cs typeface="Google Sans" pitchFamily="34" charset="-120"/>
               </a:rPr>
-              <a:t>02</a:t>
-            </a:r>
-            <a:endParaRPr lang="en-US" sz="920" dirty="0"/>
-          </a:p>
-        </p:txBody>
-      </p:sp>
-      <p:sp>
-        <p:nvSpPr>
-          <p:cNvPr id="35" name="Text 33"/>
-          <p:cNvSpPr/>
-          <p:nvPr/>
-        </p:nvSpPr>
-        <p:spPr>
-          <a:xfrm>
-            <a:off x="6781190" y="1463040"/>
-            <a:ext cx="4851806" cy="329184"/>
-          </a:xfrm>
-          <a:prstGeom prst="rect">
-            <a:avLst/>
-          </a:prstGeom>
-          <a:noFill/>
-          <a:ln/>
-        </p:spPr>
-        <p:txBody>
-          <a:bodyPr wrap="square" rtlCol="0" anchor="ctr"/>
+              <a:t>2. Why Pattern A Wins on Unit Economics</a:t>
+            </a:r>
+            <a:endParaRPr lang="en-US" sz="760" dirty="0"/>
+          </a:p>
+        </p:txBody>
+      </p:sp>
+      <p:sp>
+        <p:nvSpPr>
+          <p:cNvPr id="27" name="Text 24"/>
+          <p:cNvSpPr/>
+          <p:nvPr/>
+        </p:nvSpPr>
+        <p:spPr>
+          <a:xfrm>
+            <a:off x="3404311" y="4992624"/>
+            <a:ext cx="2499055" cy="1024128"/>
+          </a:xfrm>
+          <a:prstGeom prst="rect">
+            <a:avLst/>
+          </a:prstGeom>
+          <a:noFill/>
+          <a:ln/>
+        </p:spPr>
+        <p:txBody>
+          <a:bodyPr wrap="square" rtlCol="0" anchor="t">
+            <a:normAutofit/>
+          </a:bodyPr>
           <a:lstStyle/>
           <a:p>
             <a:pPr indent="0" marL="0">
               <a:buNone/>
             </a:pPr>
             <a:r>
-              <a:rPr lang="en-US" sz="1140" b="1" dirty="0">
-                <a:solidFill>
-                  <a:srgbClr val="3C4043"/>
-                </a:solidFill>
-                <a:latin typeface="Google Sans" pitchFamily="34" charset="0"/>
-                <a:ea typeface="Google Sans" pitchFamily="34" charset="-122"/>
-                <a:cs typeface="Google Sans" pitchFamily="34" charset="-120"/>
-              </a:rPr>
-              <a:t>Ingress, Identity &amp; Bidirectional AI Safety</a:t>
-            </a:r>
-            <a:endParaRPr lang="en-US" sz="1140" dirty="0"/>
-          </a:p>
-        </p:txBody>
-      </p:sp>
-      <p:sp>
-        <p:nvSpPr>
-          <p:cNvPr id="36" name="Shape 34"/>
-          <p:cNvSpPr/>
-          <p:nvPr/>
-        </p:nvSpPr>
-        <p:spPr>
-          <a:xfrm>
-            <a:off x="6342278" y="1847088"/>
-            <a:ext cx="5290718" cy="9144"/>
-          </a:xfrm>
-          <a:prstGeom prst="rect">
-            <a:avLst/>
-          </a:prstGeom>
-          <a:solidFill>
-            <a:srgbClr val="DADCE0"/>
-          </a:solidFill>
-          <a:ln/>
-        </p:spPr>
-      </p:sp>
-      <p:sp>
-        <p:nvSpPr>
-          <p:cNvPr id="37" name="Text 35"/>
-          <p:cNvSpPr/>
-          <p:nvPr/>
-        </p:nvSpPr>
-        <p:spPr>
-          <a:xfrm>
-            <a:off x="6342278" y="1901952"/>
-            <a:ext cx="5290718" cy="850392"/>
-          </a:xfrm>
-          <a:prstGeom prst="rect">
-            <a:avLst/>
-          </a:prstGeom>
-          <a:noFill/>
-          <a:ln/>
-        </p:spPr>
-        <p:txBody>
-          <a:bodyPr wrap="square" rtlCol="0" anchor="t"/>
-          <a:lstStyle/>
-          <a:p>
-            <a:pPr indent="0" marL="0">
-              <a:buNone/>
-            </a:pPr>
-            <a:r>
-              <a:rPr lang="en-US" sz="980" dirty="0">
+              <a:rPr lang="en-US" sz="740" dirty="0">
                 <a:solidFill>
                   <a:srgbClr val="5F6368"/>
                 </a:solidFill>
@@ -20024,188 +21655,26 @@
                 <a:ea typeface="Roboto" pitchFamily="34" charset="-122"/>
                 <a:cs typeface="Roboto" pitchFamily="34" charset="-120"/>
               </a:rPr>
-              <a:t>Global External Application Load Balancer, Google Cloud Armor L7 WAF (stripping spoofed X-Tenant-Id headers), IAP + IAM STS (RFC 8693 OBO + RFC 9449 DPoP), Vertex AI Model Armor, and Cloud Sensitive Data Protection.</a:t>
-            </a:r>
-            <a:endParaRPr lang="en-US" sz="980" dirty="0"/>
-          </a:p>
-        </p:txBody>
-      </p:sp>
-      <p:sp>
-        <p:nvSpPr>
-          <p:cNvPr id="38" name="Shape 36"/>
-          <p:cNvSpPr/>
-          <p:nvPr/>
-        </p:nvSpPr>
-        <p:spPr>
-          <a:xfrm>
-            <a:off x="6342278" y="2788920"/>
-            <a:ext cx="5290718" cy="493776"/>
+              <a:t>Delivers a $42/mo baseline per tenant and 90% shared 32k prefix cache savings (84.7% turn COGS reduction) inside one GCP project.</a:t>
+            </a:r>
+            <a:endParaRPr lang="en-US" sz="740" dirty="0"/>
+          </a:p>
+        </p:txBody>
+      </p:sp>
+      <p:sp>
+        <p:nvSpPr>
+          <p:cNvPr id="28" name="Shape 25"/>
+          <p:cNvSpPr/>
+          <p:nvPr/>
+        </p:nvSpPr>
+        <p:spPr>
+          <a:xfrm>
+            <a:off x="6177686" y="4663440"/>
+            <a:ext cx="2718511" cy="1408176"/>
           </a:xfrm>
           <a:prstGeom prst="roundRect">
             <a:avLst>
-              <a:gd name="adj" fmla="val 11111"/>
-            </a:avLst>
-          </a:prstGeom>
-          <a:solidFill>
-            <a:srgbClr val="FFFFFF"/>
-          </a:solidFill>
-          <a:ln w="9525">
-            <a:solidFill>
-              <a:srgbClr val="DADCE0"/>
-            </a:solidFill>
-            <a:prstDash val="solid"/>
-          </a:ln>
-        </p:spPr>
-      </p:sp>
-      <p:sp>
-        <p:nvSpPr>
-          <p:cNvPr id="39" name="Shape 37"/>
-          <p:cNvSpPr/>
-          <p:nvPr/>
-        </p:nvSpPr>
-        <p:spPr>
-          <a:xfrm>
-            <a:off x="6342278" y="2788920"/>
-            <a:ext cx="54864" cy="493776"/>
-          </a:xfrm>
-          <a:prstGeom prst="rect">
-            <a:avLst/>
-          </a:prstGeom>
-          <a:solidFill>
-            <a:srgbClr val="EA4335"/>
-          </a:solidFill>
-          <a:ln/>
-        </p:spPr>
-      </p:sp>
-      <p:sp>
-        <p:nvSpPr>
-          <p:cNvPr id="40" name="Text 38"/>
-          <p:cNvSpPr/>
-          <p:nvPr/>
-        </p:nvSpPr>
-        <p:spPr>
-          <a:xfrm>
-            <a:off x="6433718" y="2816352"/>
-            <a:ext cx="5162702" cy="438912"/>
-          </a:xfrm>
-          <a:prstGeom prst="rect">
-            <a:avLst/>
-          </a:prstGeom>
-          <a:noFill/>
-          <a:ln/>
-        </p:spPr>
-        <p:txBody>
-          <a:bodyPr wrap="square" rtlCol="0" anchor="ctr"/>
-          <a:lstStyle/>
-          <a:p>
-            <a:pPr indent="0" marL="0">
-              <a:buNone/>
-            </a:pPr>
-            <a:r>
-              <a:rPr lang="en-US" sz="750" b="1" dirty="0">
-                <a:solidFill>
-                  <a:srgbClr val="3C4043"/>
-                </a:solidFill>
-                <a:latin typeface="Google Sans" pitchFamily="34" charset="0"/>
-                <a:ea typeface="Google Sans" pitchFamily="34" charset="-122"/>
-                <a:cs typeface="Google Sans" pitchFamily="34" charset="-120"/>
-              </a:rPr>
-              <a:t>Cloud Stack: Cloud Load Balancing • Cloud Armor WAF • IAP &amp; IAM STS (OBO + DPoP) • Model Armor • Cloud DLP
-</a:t>
-            </a:r>
-            <a:pPr indent="0" marL="0">
-              <a:buNone/>
-            </a:pPr>
-            <a:r>
-              <a:rPr lang="en-US" sz="730" dirty="0">
-                <a:solidFill>
-                  <a:srgbClr val="5F6368"/>
-                </a:solidFill>
-                <a:latin typeface="Roboto" pitchFamily="34" charset="0"/>
-                <a:ea typeface="Roboto" pitchFamily="34" charset="-122"/>
-                <a:cs typeface="Roboto" pitchFamily="34" charset="-120"/>
-              </a:rPr>
-              <a:t>Target &amp; SLA: Strips Spoofed Headers (401), Blocks Jailbreaks (400) &amp; NLC Violations (422), Masks IBAN/PAN PII</a:t>
-            </a:r>
-            <a:endParaRPr lang="en-US" sz="750" dirty="0"/>
-          </a:p>
-        </p:txBody>
-      </p:sp>
-      <p:sp>
-        <p:nvSpPr>
-          <p:cNvPr id="41" name="Shape 39"/>
-          <p:cNvSpPr/>
-          <p:nvPr/>
-        </p:nvSpPr>
-        <p:spPr>
-          <a:xfrm>
-            <a:off x="6342278" y="3337560"/>
-            <a:ext cx="5290718" cy="219456"/>
-          </a:xfrm>
-          <a:prstGeom prst="roundRect">
-            <a:avLst>
-              <a:gd name="adj" fmla="val 20833"/>
-            </a:avLst>
-          </a:prstGeom>
-          <a:solidFill>
-            <a:srgbClr val="FCE8E6"/>
-          </a:solidFill>
-          <a:ln/>
-        </p:spPr>
-      </p:sp>
-      <p:sp>
-        <p:nvSpPr>
-          <p:cNvPr id="42" name="Text 40"/>
-          <p:cNvSpPr/>
-          <p:nvPr/>
-        </p:nvSpPr>
-        <p:spPr>
-          <a:xfrm>
-            <a:off x="6397142" y="3337560"/>
-            <a:ext cx="5180990" cy="219456"/>
-          </a:xfrm>
-          <a:prstGeom prst="rect">
-            <a:avLst/>
-          </a:prstGeom>
-          <a:noFill/>
-          <a:ln/>
-        </p:spPr>
-        <p:txBody>
-          <a:bodyPr wrap="square" rtlCol="0" anchor="ctr"/>
-          <a:lstStyle/>
-          <a:p>
-            <a:pPr indent="0" marL="0">
-              <a:buNone/>
-            </a:pPr>
-            <a:r>
-              <a:rPr lang="en-US" sz="750" b="1" dirty="0">
-                <a:solidFill>
-                  <a:srgbClr val="A50E0E"/>
-                </a:solidFill>
-                <a:latin typeface="Google Sans" pitchFamily="34" charset="0"/>
-                <a:ea typeface="Google Sans" pitchFamily="34" charset="-122"/>
-                <a:cs typeface="Google Sans" pitchFamily="34" charset="-120"/>
-              </a:rPr>
-              <a:t>2. Ingress, Identity &amp; Safety</a:t>
-            </a:r>
-            <a:endParaRPr lang="en-US" sz="750" dirty="0"/>
-          </a:p>
-        </p:txBody>
-      </p:sp>
-      <p:sp>
-        <p:nvSpPr>
-          <p:cNvPr id="43" name="Shape 41"/>
-          <p:cNvSpPr/>
-          <p:nvPr/>
-        </p:nvSpPr>
-        <p:spPr>
-          <a:xfrm>
-            <a:off x="411480" y="3776472"/>
-            <a:ext cx="5583326" cy="2258568"/>
-          </a:xfrm>
-          <a:prstGeom prst="roundRect">
-            <a:avLst>
-              <a:gd name="adj" fmla="val 3239"/>
+              <a:gd name="adj" fmla="val 5195"/>
             </a:avLst>
           </a:prstGeom>
           <a:solidFill>
@@ -20221,14 +21690,14 @@
       </p:sp>
       <p:sp>
         <p:nvSpPr>
-          <p:cNvPr id="44" name="Shape 42"/>
-          <p:cNvSpPr/>
-          <p:nvPr/>
-        </p:nvSpPr>
-        <p:spPr>
-          <a:xfrm>
-            <a:off x="411480" y="3776472"/>
-            <a:ext cx="5583326" cy="59436"/>
+          <p:cNvPr id="29" name="Shape 26"/>
+          <p:cNvSpPr/>
+          <p:nvPr/>
+        </p:nvSpPr>
+        <p:spPr>
+          <a:xfrm>
+            <a:off x="6177686" y="4663440"/>
+            <a:ext cx="2718511" cy="50292"/>
           </a:xfrm>
           <a:prstGeom prst="rect">
             <a:avLst/>
@@ -20241,150 +21710,73 @@
       </p:sp>
       <p:sp>
         <p:nvSpPr>
-          <p:cNvPr id="45" name="Shape 43"/>
-          <p:cNvSpPr/>
-          <p:nvPr/>
-        </p:nvSpPr>
-        <p:spPr>
-          <a:xfrm>
-            <a:off x="557784" y="3904488"/>
-            <a:ext cx="365760" cy="256032"/>
-          </a:xfrm>
-          <a:prstGeom prst="roundRect">
-            <a:avLst>
-              <a:gd name="adj" fmla="val 21429"/>
-            </a:avLst>
-          </a:prstGeom>
-          <a:solidFill>
-            <a:srgbClr val="FEF7E0"/>
-          </a:solidFill>
-          <a:ln/>
-        </p:spPr>
-      </p:sp>
-      <p:sp>
-        <p:nvSpPr>
-          <p:cNvPr id="46" name="Text 44"/>
-          <p:cNvSpPr/>
-          <p:nvPr/>
-        </p:nvSpPr>
-        <p:spPr>
-          <a:xfrm>
-            <a:off x="557784" y="3904488"/>
-            <a:ext cx="365760" cy="256032"/>
-          </a:xfrm>
-          <a:prstGeom prst="rect">
-            <a:avLst/>
-          </a:prstGeom>
-          <a:noFill/>
-          <a:ln/>
-        </p:spPr>
-        <p:txBody>
-          <a:bodyPr wrap="square" rtlCol="0" anchor="ctr"/>
-          <a:lstStyle/>
-          <a:p>
-            <a:pPr algn="ctr" indent="0" marL="0">
-              <a:buNone/>
-            </a:pPr>
-            <a:r>
-              <a:rPr lang="en-US" sz="920" b="1" dirty="0">
-                <a:solidFill>
-                  <a:srgbClr val="B06000"/>
+          <p:cNvPr id="30" name="Text 27"/>
+          <p:cNvSpPr/>
+          <p:nvPr/>
+        </p:nvSpPr>
+        <p:spPr>
+          <a:xfrm>
+            <a:off x="6287414" y="4736592"/>
+            <a:ext cx="2499055" cy="256032"/>
+          </a:xfrm>
+          <a:prstGeom prst="rect">
+            <a:avLst/>
+          </a:prstGeom>
+          <a:noFill/>
+          <a:ln/>
+        </p:spPr>
+        <p:txBody>
+          <a:bodyPr wrap="square" rtlCol="0" anchor="ctr">
+            <a:normAutofit/>
+          </a:bodyPr>
+          <a:lstStyle/>
+          <a:p>
+            <a:pPr indent="0" marL="0">
+              <a:buNone/>
+            </a:pPr>
+            <a:r>
+              <a:rPr lang="en-US" sz="760" b="1" dirty="0">
+                <a:solidFill>
+                  <a:srgbClr val="3C4043"/>
                 </a:solidFill>
                 <a:latin typeface="Google Sans" pitchFamily="34" charset="0"/>
                 <a:ea typeface="Google Sans" pitchFamily="34" charset="-122"/>
                 <a:cs typeface="Google Sans" pitchFamily="34" charset="-120"/>
               </a:rPr>
-              <a:t>03</a:t>
-            </a:r>
-            <a:endParaRPr lang="en-US" sz="920" dirty="0"/>
-          </a:p>
-        </p:txBody>
-      </p:sp>
-      <p:sp>
-        <p:nvSpPr>
-          <p:cNvPr id="47" name="Text 45"/>
-          <p:cNvSpPr/>
-          <p:nvPr/>
-        </p:nvSpPr>
-        <p:spPr>
-          <a:xfrm>
-            <a:off x="996696" y="3886200"/>
-            <a:ext cx="4851806" cy="329184"/>
-          </a:xfrm>
-          <a:prstGeom prst="rect">
-            <a:avLst/>
-          </a:prstGeom>
-          <a:noFill/>
-          <a:ln/>
-        </p:spPr>
-        <p:txBody>
-          <a:bodyPr wrap="square" rtlCol="0" anchor="ctr"/>
+              <a:t>3. Cryptographic Equivalence in a Pool</a:t>
+            </a:r>
+            <a:endParaRPr lang="en-US" sz="760" dirty="0"/>
+          </a:p>
+        </p:txBody>
+      </p:sp>
+      <p:sp>
+        <p:nvSpPr>
+          <p:cNvPr id="31" name="Text 28"/>
+          <p:cNvSpPr/>
+          <p:nvPr/>
+        </p:nvSpPr>
+        <p:spPr>
+          <a:xfrm>
+            <a:off x="6287414" y="4992624"/>
+            <a:ext cx="2499055" cy="1024128"/>
+          </a:xfrm>
+          <a:prstGeom prst="rect">
+            <a:avLst/>
+          </a:prstGeom>
+          <a:noFill/>
+          <a:ln/>
+        </p:spPr>
+        <p:txBody>
+          <a:bodyPr wrap="square" rtlCol="0" anchor="t">
+            <a:normAutofit/>
+          </a:bodyPr>
           <a:lstStyle/>
           <a:p>
             <a:pPr indent="0" marL="0">
               <a:buNone/>
             </a:pPr>
             <a:r>
-              <a:rPr lang="en-US" sz="1140" b="1" dirty="0">
-                <a:solidFill>
-                  <a:srgbClr val="3C4043"/>
-                </a:solidFill>
-                <a:latin typeface="Google Sans" pitchFamily="34" charset="0"/>
-                <a:ea typeface="Google Sans" pitchFamily="34" charset="-122"/>
-                <a:cs typeface="Google Sans" pitchFamily="34" charset="-120"/>
-              </a:rPr>
-              <a:t>Rate Bulkheads, Relational RLS &amp; FinOps Telemetry</a:t>
-            </a:r>
-            <a:endParaRPr lang="en-US" sz="1140" dirty="0"/>
-          </a:p>
-        </p:txBody>
-      </p:sp>
-      <p:sp>
-        <p:nvSpPr>
-          <p:cNvPr id="48" name="Shape 46"/>
-          <p:cNvSpPr/>
-          <p:nvPr/>
-        </p:nvSpPr>
-        <p:spPr>
-          <a:xfrm>
-            <a:off x="557784" y="4270248"/>
-            <a:ext cx="5290718" cy="9144"/>
-          </a:xfrm>
-          <a:prstGeom prst="rect">
-            <a:avLst/>
-          </a:prstGeom>
-          <a:solidFill>
-            <a:srgbClr val="DADCE0"/>
-          </a:solidFill>
-          <a:ln/>
-        </p:spPr>
-      </p:sp>
-      <p:sp>
-        <p:nvSpPr>
-          <p:cNvPr id="49" name="Text 47"/>
-          <p:cNvSpPr/>
-          <p:nvPr/>
-        </p:nvSpPr>
-        <p:spPr>
-          <a:xfrm>
-            <a:off x="557784" y="4325112"/>
-            <a:ext cx="5290718" cy="850392"/>
-          </a:xfrm>
-          <a:prstGeom prst="rect">
-            <a:avLst/>
-          </a:prstGeom>
-          <a:noFill/>
-          <a:ln/>
-        </p:spPr>
-        <p:txBody>
-          <a:bodyPr wrap="square" rtlCol="0" anchor="t"/>
-          <a:lstStyle/>
-          <a:p>
-            <a:pPr indent="0" marL="0">
-              <a:buNone/>
-            </a:pPr>
-            <a:r>
-              <a:rPr lang="en-US" sz="980" dirty="0">
+              <a:rPr lang="en-US" sz="740" dirty="0">
                 <a:solidFill>
                   <a:srgbClr val="5F6368"/>
                 </a:solidFill>
@@ -20392,188 +21784,26 @@
                 <a:ea typeface="Roboto" pitchFamily="34" charset="-122"/>
                 <a:cs typeface="Roboto" pitchFamily="34" charset="-120"/>
               </a:rPr>
-              <a:t>Memorystore for Valkey (120 vs. 600 RPM token buckets), Firestore tenant profile registry, AlloyDB for PostgreSQL (FORCE ROW LEVEL SECURITY), Cloud KMS CMEK, and BigQuery zero-PII OTel chargeback.</a:t>
-            </a:r>
-            <a:endParaRPr lang="en-US" sz="980" dirty="0"/>
-          </a:p>
-        </p:txBody>
-      </p:sp>
-      <p:sp>
-        <p:nvSpPr>
-          <p:cNvPr id="50" name="Shape 48"/>
-          <p:cNvSpPr/>
-          <p:nvPr/>
-        </p:nvSpPr>
-        <p:spPr>
-          <a:xfrm>
-            <a:off x="557784" y="5212080"/>
-            <a:ext cx="5290718" cy="493776"/>
+              <a:t>Enforces RFC 8693 + DPoP (Hop 1), Catalog PDP (Hop 2), Valkey bulkheads (Hop 3), Model Armor + SDP (Hop 4), and AlloyDB FORCE RLS (Hop 5).</a:t>
+            </a:r>
+            <a:endParaRPr lang="en-US" sz="740" dirty="0"/>
+          </a:p>
+        </p:txBody>
+      </p:sp>
+      <p:sp>
+        <p:nvSpPr>
+          <p:cNvPr id="32" name="Shape 29"/>
+          <p:cNvSpPr/>
+          <p:nvPr/>
+        </p:nvSpPr>
+        <p:spPr>
+          <a:xfrm>
+            <a:off x="9060790" y="4663440"/>
+            <a:ext cx="2718511" cy="1408176"/>
           </a:xfrm>
           <a:prstGeom prst="roundRect">
             <a:avLst>
-              <a:gd name="adj" fmla="val 11111"/>
-            </a:avLst>
-          </a:prstGeom>
-          <a:solidFill>
-            <a:srgbClr val="FFFFFF"/>
-          </a:solidFill>
-          <a:ln w="9525">
-            <a:solidFill>
-              <a:srgbClr val="DADCE0"/>
-            </a:solidFill>
-            <a:prstDash val="solid"/>
-          </a:ln>
-        </p:spPr>
-      </p:sp>
-      <p:sp>
-        <p:nvSpPr>
-          <p:cNvPr id="51" name="Shape 49"/>
-          <p:cNvSpPr/>
-          <p:nvPr/>
-        </p:nvSpPr>
-        <p:spPr>
-          <a:xfrm>
-            <a:off x="557784" y="5212080"/>
-            <a:ext cx="54864" cy="493776"/>
-          </a:xfrm>
-          <a:prstGeom prst="rect">
-            <a:avLst/>
-          </a:prstGeom>
-          <a:solidFill>
-            <a:srgbClr val="FBBC04"/>
-          </a:solidFill>
-          <a:ln/>
-        </p:spPr>
-      </p:sp>
-      <p:sp>
-        <p:nvSpPr>
-          <p:cNvPr id="52" name="Text 50"/>
-          <p:cNvSpPr/>
-          <p:nvPr/>
-        </p:nvSpPr>
-        <p:spPr>
-          <a:xfrm>
-            <a:off x="649224" y="5239512"/>
-            <a:ext cx="5162702" cy="438912"/>
-          </a:xfrm>
-          <a:prstGeom prst="rect">
-            <a:avLst/>
-          </a:prstGeom>
-          <a:noFill/>
-          <a:ln/>
-        </p:spPr>
-        <p:txBody>
-          <a:bodyPr wrap="square" rtlCol="0" anchor="ctr"/>
-          <a:lstStyle/>
-          <a:p>
-            <a:pPr indent="0" marL="0">
-              <a:buNone/>
-            </a:pPr>
-            <a:r>
-              <a:rPr lang="en-US" sz="750" b="1" dirty="0">
-                <a:solidFill>
-                  <a:srgbClr val="3C4043"/>
-                </a:solidFill>
-                <a:latin typeface="Google Sans" pitchFamily="34" charset="0"/>
-                <a:ea typeface="Google Sans" pitchFamily="34" charset="-122"/>
-                <a:cs typeface="Google Sans" pitchFamily="34" charset="-120"/>
-              </a:rPr>
-              <a:t>Cloud Stack: Memorystore for Valkey (RPM) • Firestore • AlloyDB PostgreSQL RLS • Cloud KMS • BigQuery OTel
-</a:t>
-            </a:r>
-            <a:pPr indent="0" marL="0">
-              <a:buNone/>
-            </a:pPr>
-            <a:r>
-              <a:rPr lang="en-US" sz="730" dirty="0">
-                <a:solidFill>
-                  <a:srgbClr val="5F6368"/>
-                </a:solidFill>
-                <a:latin typeface="Roboto" pitchFamily="34" charset="0"/>
-                <a:ea typeface="Roboto" pitchFamily="34" charset="-122"/>
-                <a:cs typeface="Roboto" pitchFamily="34" charset="-120"/>
-              </a:rPr>
-              <a:t>Target &amp; SLA: Enforces 120/600 RPM &amp; 4k/8k Thinking Caps • 0 Cross-Tenant SQL Rows • Per-Tenant Token Billing</a:t>
-            </a:r>
-            <a:endParaRPr lang="en-US" sz="750" dirty="0"/>
-          </a:p>
-        </p:txBody>
-      </p:sp>
-      <p:sp>
-        <p:nvSpPr>
-          <p:cNvPr id="53" name="Shape 51"/>
-          <p:cNvSpPr/>
-          <p:nvPr/>
-        </p:nvSpPr>
-        <p:spPr>
-          <a:xfrm>
-            <a:off x="557784" y="5760720"/>
-            <a:ext cx="5290718" cy="219456"/>
-          </a:xfrm>
-          <a:prstGeom prst="roundRect">
-            <a:avLst>
-              <a:gd name="adj" fmla="val 20833"/>
-            </a:avLst>
-          </a:prstGeom>
-          <a:solidFill>
-            <a:srgbClr val="FEF7E0"/>
-          </a:solidFill>
-          <a:ln/>
-        </p:spPr>
-      </p:sp>
-      <p:sp>
-        <p:nvSpPr>
-          <p:cNvPr id="54" name="Text 52"/>
-          <p:cNvSpPr/>
-          <p:nvPr/>
-        </p:nvSpPr>
-        <p:spPr>
-          <a:xfrm>
-            <a:off x="612648" y="5760720"/>
-            <a:ext cx="5180990" cy="219456"/>
-          </a:xfrm>
-          <a:prstGeom prst="rect">
-            <a:avLst/>
-          </a:prstGeom>
-          <a:noFill/>
-          <a:ln/>
-        </p:spPr>
-        <p:txBody>
-          <a:bodyPr wrap="square" rtlCol="0" anchor="ctr"/>
-          <a:lstStyle/>
-          <a:p>
-            <a:pPr indent="0" marL="0">
-              <a:buNone/>
-            </a:pPr>
-            <a:r>
-              <a:rPr lang="en-US" sz="750" b="1" dirty="0">
-                <a:solidFill>
-                  <a:srgbClr val="B06000"/>
-                </a:solidFill>
-                <a:latin typeface="Google Sans" pitchFamily="34" charset="0"/>
-                <a:ea typeface="Google Sans" pitchFamily="34" charset="-122"/>
-                <a:cs typeface="Google Sans" pitchFamily="34" charset="-120"/>
-              </a:rPr>
-              <a:t>3. Bulkheads, RLS &amp; FinOps</a:t>
-            </a:r>
-            <a:endParaRPr lang="en-US" sz="750" dirty="0"/>
-          </a:p>
-        </p:txBody>
-      </p:sp>
-      <p:sp>
-        <p:nvSpPr>
-          <p:cNvPr id="55" name="Shape 53"/>
-          <p:cNvSpPr/>
-          <p:nvPr/>
-        </p:nvSpPr>
-        <p:spPr>
-          <a:xfrm>
-            <a:off x="6195974" y="3776472"/>
-            <a:ext cx="5583326" cy="2258568"/>
-          </a:xfrm>
-          <a:prstGeom prst="roundRect">
-            <a:avLst>
-              <a:gd name="adj" fmla="val 3239"/>
+              <a:gd name="adj" fmla="val 5195"/>
             </a:avLst>
           </a:prstGeom>
           <a:solidFill>
@@ -20589,14 +21819,14 @@
       </p:sp>
       <p:sp>
         <p:nvSpPr>
-          <p:cNvPr id="56" name="Shape 54"/>
-          <p:cNvSpPr/>
-          <p:nvPr/>
-        </p:nvSpPr>
-        <p:spPr>
-          <a:xfrm>
-            <a:off x="6195974" y="3776472"/>
-            <a:ext cx="5583326" cy="59436"/>
+          <p:cNvPr id="33" name="Shape 30"/>
+          <p:cNvSpPr/>
+          <p:nvPr/>
+        </p:nvSpPr>
+        <p:spPr>
+          <a:xfrm>
+            <a:off x="9060790" y="4663440"/>
+            <a:ext cx="2718511" cy="50292"/>
           </a:xfrm>
           <a:prstGeom prst="rect">
             <a:avLst/>
@@ -20609,150 +21839,73 @@
       </p:sp>
       <p:sp>
         <p:nvSpPr>
-          <p:cNvPr id="57" name="Shape 55"/>
-          <p:cNvSpPr/>
-          <p:nvPr/>
-        </p:nvSpPr>
-        <p:spPr>
-          <a:xfrm>
-            <a:off x="6342278" y="3904488"/>
-            <a:ext cx="365760" cy="256032"/>
-          </a:xfrm>
-          <a:prstGeom prst="roundRect">
-            <a:avLst>
-              <a:gd name="adj" fmla="val 21429"/>
-            </a:avLst>
-          </a:prstGeom>
-          <a:solidFill>
-            <a:srgbClr val="E6F4EA"/>
-          </a:solidFill>
-          <a:ln/>
-        </p:spPr>
-      </p:sp>
-      <p:sp>
-        <p:nvSpPr>
-          <p:cNvPr id="58" name="Text 56"/>
-          <p:cNvSpPr/>
-          <p:nvPr/>
-        </p:nvSpPr>
-        <p:spPr>
-          <a:xfrm>
-            <a:off x="6342278" y="3904488"/>
-            <a:ext cx="365760" cy="256032"/>
-          </a:xfrm>
-          <a:prstGeom prst="rect">
-            <a:avLst/>
-          </a:prstGeom>
-          <a:noFill/>
-          <a:ln/>
-        </p:spPr>
-        <p:txBody>
-          <a:bodyPr wrap="square" rtlCol="0" anchor="ctr"/>
-          <a:lstStyle/>
-          <a:p>
-            <a:pPr algn="ctr" indent="0" marL="0">
-              <a:buNone/>
-            </a:pPr>
-            <a:r>
-              <a:rPr lang="en-US" sz="920" b="1" dirty="0">
-                <a:solidFill>
-                  <a:srgbClr val="0D652D"/>
+          <p:cNvPr id="34" name="Text 31"/>
+          <p:cNvSpPr/>
+          <p:nvPr/>
+        </p:nvSpPr>
+        <p:spPr>
+          <a:xfrm>
+            <a:off x="9170518" y="4736592"/>
+            <a:ext cx="2499055" cy="256032"/>
+          </a:xfrm>
+          <a:prstGeom prst="rect">
+            <a:avLst/>
+          </a:prstGeom>
+          <a:noFill/>
+          <a:ln/>
+        </p:spPr>
+        <p:txBody>
+          <a:bodyPr wrap="square" rtlCol="0" anchor="ctr">
+            <a:normAutofit/>
+          </a:bodyPr>
+          <a:lstStyle/>
+          <a:p>
+            <a:pPr indent="0" marL="0">
+              <a:buNone/>
+            </a:pPr>
+            <a:r>
+              <a:rPr lang="en-US" sz="760" b="1" dirty="0">
+                <a:solidFill>
+                  <a:srgbClr val="3C4043"/>
                 </a:solidFill>
                 <a:latin typeface="Google Sans" pitchFamily="34" charset="0"/>
                 <a:ea typeface="Google Sans" pitchFamily="34" charset="-122"/>
                 <a:cs typeface="Google Sans" pitchFamily="34" charset="-120"/>
               </a:rPr>
-              <a:t>04</a:t>
-            </a:r>
-            <a:endParaRPr lang="en-US" sz="920" dirty="0"/>
-          </a:p>
-        </p:txBody>
-      </p:sp>
-      <p:sp>
-        <p:nvSpPr>
-          <p:cNvPr id="59" name="Text 57"/>
-          <p:cNvSpPr/>
-          <p:nvPr/>
-        </p:nvSpPr>
-        <p:spPr>
-          <a:xfrm>
-            <a:off x="6781190" y="3886200"/>
-            <a:ext cx="4851806" cy="329184"/>
-          </a:xfrm>
-          <a:prstGeom prst="rect">
-            <a:avLst/>
-          </a:prstGeom>
-          <a:noFill/>
-          <a:ln/>
-        </p:spPr>
-        <p:txBody>
-          <a:bodyPr wrap="square" rtlCol="0" anchor="ctr"/>
+              <a:t>4. Clear Graduation Trigger to Pattern B / C</a:t>
+            </a:r>
+            <a:endParaRPr lang="en-US" sz="760" dirty="0"/>
+          </a:p>
+        </p:txBody>
+      </p:sp>
+      <p:sp>
+        <p:nvSpPr>
+          <p:cNvPr id="35" name="Text 32"/>
+          <p:cNvSpPr/>
+          <p:nvPr/>
+        </p:nvSpPr>
+        <p:spPr>
+          <a:xfrm>
+            <a:off x="9170518" y="4992624"/>
+            <a:ext cx="2499055" cy="1024128"/>
+          </a:xfrm>
+          <a:prstGeom prst="rect">
+            <a:avLst/>
+          </a:prstGeom>
+          <a:noFill/>
+          <a:ln/>
+        </p:spPr>
+        <p:txBody>
+          <a:bodyPr wrap="square" rtlCol="0" anchor="t">
+            <a:normAutofit/>
+          </a:bodyPr>
           <a:lstStyle/>
           <a:p>
             <a:pPr indent="0" marL="0">
               <a:buNone/>
             </a:pPr>
             <a:r>
-              <a:rPr lang="en-US" sz="1140" b="1" dirty="0">
-                <a:solidFill>
-                  <a:srgbClr val="3C4043"/>
-                </a:solidFill>
-                <a:latin typeface="Google Sans" pitchFamily="34" charset="0"/>
-                <a:ea typeface="Google Sans" pitchFamily="34" charset="-122"/>
-                <a:cs typeface="Google Sans" pitchFamily="34" charset="-120"/>
-              </a:rPr>
-              <a:t>High-Density Unit Economics ($42/Tenant/Month)</a:t>
-            </a:r>
-            <a:endParaRPr lang="en-US" sz="1140" dirty="0"/>
-          </a:p>
-        </p:txBody>
-      </p:sp>
-      <p:sp>
-        <p:nvSpPr>
-          <p:cNvPr id="60" name="Shape 58"/>
-          <p:cNvSpPr/>
-          <p:nvPr/>
-        </p:nvSpPr>
-        <p:spPr>
-          <a:xfrm>
-            <a:off x="6342278" y="4270248"/>
-            <a:ext cx="5290718" cy="9144"/>
-          </a:xfrm>
-          <a:prstGeom prst="rect">
-            <a:avLst/>
-          </a:prstGeom>
-          <a:solidFill>
-            <a:srgbClr val="DADCE0"/>
-          </a:solidFill>
-          <a:ln/>
-        </p:spPr>
-      </p:sp>
-      <p:sp>
-        <p:nvSpPr>
-          <p:cNvPr id="61" name="Text 59"/>
-          <p:cNvSpPr/>
-          <p:nvPr/>
-        </p:nvSpPr>
-        <p:spPr>
-          <a:xfrm>
-            <a:off x="6342278" y="4325112"/>
-            <a:ext cx="5290718" cy="850392"/>
-          </a:xfrm>
-          <a:prstGeom prst="rect">
-            <a:avLst/>
-          </a:prstGeom>
-          <a:noFill/>
-          <a:ln/>
-        </p:spPr>
-        <p:txBody>
-          <a:bodyPr wrap="square" rtlCol="0" anchor="t"/>
-          <a:lstStyle/>
-          <a:p>
-            <a:pPr indent="0" marL="0">
-              <a:buNone/>
-            </a:pPr>
-            <a:r>
-              <a:rPr lang="en-US" sz="980" dirty="0">
+              <a:rPr lang="en-US" sz="740" dirty="0">
                 <a:solidFill>
                   <a:srgbClr val="5F6368"/>
                 </a:solidFill>
@@ -20760,177 +21913,15 @@
                 <a:ea typeface="Roboto" pitchFamily="34" charset="-122"/>
                 <a:cs typeface="Roboto" pitchFamily="34" charset="-120"/>
               </a:rPr>
-              <a:t>Co-hosts hundreds of commercial B2B SaaS tenants inside one shared Google Cloud project (ramp-portal-dev) while guaranteeing 10/10 red-team breach isolation.</a:t>
-            </a:r>
-            <a:endParaRPr lang="en-US" sz="980" dirty="0"/>
-          </a:p>
-        </p:txBody>
-      </p:sp>
-      <p:sp>
-        <p:nvSpPr>
-          <p:cNvPr id="62" name="Shape 60"/>
-          <p:cNvSpPr/>
-          <p:nvPr/>
-        </p:nvSpPr>
-        <p:spPr>
-          <a:xfrm>
-            <a:off x="6342278" y="5212080"/>
-            <a:ext cx="5290718" cy="493776"/>
-          </a:xfrm>
-          <a:prstGeom prst="roundRect">
-            <a:avLst>
-              <a:gd name="adj" fmla="val 11111"/>
-            </a:avLst>
-          </a:prstGeom>
-          <a:solidFill>
-            <a:srgbClr val="FFFFFF"/>
-          </a:solidFill>
-          <a:ln w="9525">
-            <a:solidFill>
-              <a:srgbClr val="DADCE0"/>
-            </a:solidFill>
-            <a:prstDash val="solid"/>
-          </a:ln>
-        </p:spPr>
-      </p:sp>
-      <p:sp>
-        <p:nvSpPr>
-          <p:cNvPr id="63" name="Shape 61"/>
-          <p:cNvSpPr/>
-          <p:nvPr/>
-        </p:nvSpPr>
-        <p:spPr>
-          <a:xfrm>
-            <a:off x="6342278" y="5212080"/>
-            <a:ext cx="54864" cy="493776"/>
-          </a:xfrm>
-          <a:prstGeom prst="rect">
-            <a:avLst/>
-          </a:prstGeom>
-          <a:solidFill>
-            <a:srgbClr val="34A853"/>
-          </a:solidFill>
-          <a:ln/>
-        </p:spPr>
-      </p:sp>
-      <p:sp>
-        <p:nvSpPr>
-          <p:cNvPr id="64" name="Text 62"/>
-          <p:cNvSpPr/>
-          <p:nvPr/>
-        </p:nvSpPr>
-        <p:spPr>
-          <a:xfrm>
-            <a:off x="6433718" y="5239512"/>
-            <a:ext cx="5162702" cy="438912"/>
-          </a:xfrm>
-          <a:prstGeom prst="rect">
-            <a:avLst/>
-          </a:prstGeom>
-          <a:noFill/>
-          <a:ln/>
-        </p:spPr>
-        <p:txBody>
-          <a:bodyPr wrap="square" rtlCol="0" anchor="ctr"/>
-          <a:lstStyle/>
-          <a:p>
-            <a:pPr indent="0" marL="0">
-              <a:buNone/>
-            </a:pPr>
-            <a:r>
-              <a:rPr lang="en-US" sz="750" b="1" dirty="0">
-                <a:solidFill>
-                  <a:srgbClr val="3C4043"/>
-                </a:solidFill>
-                <a:latin typeface="Google Sans" pitchFamily="34" charset="0"/>
-                <a:ea typeface="Google Sans" pitchFamily="34" charset="-122"/>
-                <a:cs typeface="Google Sans" pitchFamily="34" charset="-120"/>
-              </a:rPr>
-              <a:t>Cloud Stack: workstream-2-pattern-a-pooled/2.6-terraform-starter (main.tf, variables.tf) + 2.4 Codelab
-</a:t>
-            </a:r>
-            <a:pPr indent="0" marL="0">
-              <a:buNone/>
-            </a:pPr>
-            <a:r>
-              <a:rPr lang="en-US" sz="730" dirty="0">
-                <a:solidFill>
-                  <a:srgbClr val="5F6368"/>
-                </a:solidFill>
-                <a:latin typeface="Roboto" pitchFamily="34" charset="0"/>
-                <a:ea typeface="Roboto" pitchFamily="34" charset="-122"/>
-                <a:cs typeface="Roboto" pitchFamily="34" charset="-120"/>
-              </a:rPr>
-              <a:t>Target &amp; SLA: $42/mo Baseline Unit Cost per Tenant • 10/10 Red-Team Breach Simulations Verified</a:t>
-            </a:r>
-            <a:endParaRPr lang="en-US" sz="750" dirty="0"/>
-          </a:p>
-        </p:txBody>
-      </p:sp>
-      <p:sp>
-        <p:nvSpPr>
-          <p:cNvPr id="65" name="Shape 63"/>
-          <p:cNvSpPr/>
-          <p:nvPr/>
-        </p:nvSpPr>
-        <p:spPr>
-          <a:xfrm>
-            <a:off x="6342278" y="5760720"/>
-            <a:ext cx="5290718" cy="219456"/>
-          </a:xfrm>
-          <a:prstGeom prst="roundRect">
-            <a:avLst>
-              <a:gd name="adj" fmla="val 20833"/>
-            </a:avLst>
-          </a:prstGeom>
-          <a:solidFill>
-            <a:srgbClr val="E6F4EA"/>
-          </a:solidFill>
-          <a:ln/>
-        </p:spPr>
-      </p:sp>
-      <p:sp>
-        <p:nvSpPr>
-          <p:cNvPr id="66" name="Text 64"/>
-          <p:cNvSpPr/>
-          <p:nvPr/>
-        </p:nvSpPr>
-        <p:spPr>
-          <a:xfrm>
-            <a:off x="6397142" y="5760720"/>
-            <a:ext cx="5180990" cy="219456"/>
-          </a:xfrm>
-          <a:prstGeom prst="rect">
-            <a:avLst/>
-          </a:prstGeom>
-          <a:noFill/>
-          <a:ln/>
-        </p:spPr>
-        <p:txBody>
-          <a:bodyPr wrap="square" rtlCol="0" anchor="ctr"/>
-          <a:lstStyle/>
-          <a:p>
-            <a:pPr indent="0" marL="0">
-              <a:buNone/>
-            </a:pPr>
-            <a:r>
-              <a:rPr lang="en-US" sz="750" b="1" dirty="0">
-                <a:solidFill>
-                  <a:srgbClr val="0D652D"/>
-                </a:solidFill>
-                <a:latin typeface="Google Sans" pitchFamily="34" charset="0"/>
-                <a:ea typeface="Google Sans" pitchFamily="34" charset="-122"/>
-                <a:cs typeface="Google Sans" pitchFamily="34" charset="-120"/>
-              </a:rPr>
-              <a:t>4. Turnkey Pattern A Kit</a:t>
-            </a:r>
-            <a:endParaRPr lang="en-US" sz="750" dirty="0"/>
-          </a:p>
-        </p:txBody>
-      </p:sp>
-      <p:sp>
-        <p:nvSpPr>
-          <p:cNvPr id="67" name="Shape 65"/>
+              <a:t>Promote a tenant out of the shared pool only when contracts mandate a dedicated GCP project, VPC-SC perimeter, or air-gapped Gemma 3 GPUs.</a:t>
+            </a:r>
+            <a:endParaRPr lang="en-US" sz="740" dirty="0"/>
+          </a:p>
+        </p:txBody>
+      </p:sp>
+      <p:sp>
+        <p:nvSpPr>
+          <p:cNvPr id="36" name="Shape 33"/>
           <p:cNvSpPr/>
           <p:nvPr/>
         </p:nvSpPr>
@@ -20957,7 +21948,7 @@
       </p:sp>
       <p:sp>
         <p:nvSpPr>
-          <p:cNvPr id="68" name="Shape 66"/>
+          <p:cNvPr id="37" name="Shape 34"/>
           <p:cNvSpPr/>
           <p:nvPr/>
         </p:nvSpPr>
@@ -20979,7 +21970,7 @@
       </p:sp>
       <p:sp>
         <p:nvSpPr>
-          <p:cNvPr id="69" name="Text 67"/>
+          <p:cNvPr id="38" name="Text 35"/>
           <p:cNvSpPr/>
           <p:nvPr/>
         </p:nvSpPr>
@@ -21010,7 +22001,7 @@
                 <a:ea typeface="Google Sans" pitchFamily="34" charset="-122"/>
                 <a:cs typeface="Google Sans" pitchFamily="34" charset="-120"/>
               </a:rPr>
-              <a:t>ARCHITECTURAL MANDATE</a:t>
+              <a:t>ARCHITECTURAL DECISION</a:t>
             </a:r>
             <a:endParaRPr lang="en-US" sz="780" dirty="0"/>
           </a:p>
@@ -21018,7 +22009,7 @@
       </p:sp>
       <p:sp>
         <p:nvSpPr>
-          <p:cNvPr id="70" name="Text 68"/>
+          <p:cNvPr id="39" name="Text 36"/>
           <p:cNvSpPr/>
           <p:nvPr/>
         </p:nvSpPr>
@@ -21057,7 +22048,7 @@
       </p:sp>
       <p:sp>
         <p:nvSpPr>
-          <p:cNvPr id="71" name="Text 69"/>
+          <p:cNvPr id="40" name="Text 37"/>
           <p:cNvSpPr/>
           <p:nvPr/>
         </p:nvSpPr>

</xml_diff>

<commit_message>
feat(ws1): align WS1 blog, 1.1-1.4 deliverables, 5-Hop runtime, tests, UI, and 11-slide deck
</commit_message>
<xml_diff>
--- a/slides/doc-mt-02-editable-slides.pptx
+++ b/slides/doc-mt-02-editable-slides.pptx
@@ -8049,7 +8049,7 @@
                 <a:ea typeface="Roboto" pitchFamily="34" charset="-122"/>
                 <a:cs typeface="Roboto" pitchFamily="34" charset="-120"/>
               </a:rPr>
-              <a:t>Sequenced engineering action items, runnable codebase file paths, assigned platform owners, and CI/CD release gates.</a:t>
+              <a:t>Terraform 2.6 pooled starter, AlloyDB FORCE RLS policies and run_breach_simulations.py (10/10) before the series moves to Pattern B.</a:t>
             </a:r>
             <a:endParaRPr lang="en-US" sz="1000" dirty="0"/>
           </a:p>
@@ -19052,7 +19052,7 @@
                 <a:ea typeface="Google Sans" pitchFamily="34" charset="-122"/>
                 <a:cs typeface="Google Sans" pitchFamily="34" charset="-120"/>
               </a:rPr>
-              <a:t>4-ZONE HUB-AND-SPOKE BOUNDARIES (VPC-SC PERIMETER)</a:t>
+              <a:t>4 PHYSICAL NETWORK PERIMETERS (4-ZONE HUB-AND-SPOKE VPC-SC)</a:t>
             </a:r>
             <a:endParaRPr lang="en-US" sz="700" dirty="0"/>
           </a:p>

</xml_diff>